<commit_message>
docs: update presentation deck and README for OpenAI Codex architecture
</commit_message>
<xml_diff>
--- a/Vyapar_Mandap_Presentation.pptx
+++ b/Vyapar_Mandap_Presentation.pptx
@@ -3185,7 +3185,7 @@
               </a:defRPr>
             </a:pPr>
             <a:r>
-              <a:t>Modern Multi-Agent Double-Entry Accounting Platform</a:t>
+              <a:t>Built Using Codex AI Engine Architecture</a:t>
             </a:r>
           </a:p>
           <a:p>
@@ -3201,7 +3201,7 @@
               </a:defRPr>
             </a:pPr>
             <a:r>
-              <a:t>Powered by Google Gemini 2.5 Flash Vision OCR, deterministic ledger engine, and real-time GST/TDS compliance tracking.</a:t>
+              <a:t>Engineered with OpenAI Codex intelligence, coupling vision OCR parsing with a deterministic double-entry ledger core (Debits = Credits) and 1-click CA human approvals.</a:t>
             </a:r>
           </a:p>
         </p:txBody>
@@ -3441,7 +3441,7 @@
           <a:lstStyle/>
           <a:p>
             <a:pPr>
-              <a:defRPr sz="1800" b="1">
+              <a:defRPr sz="1700" b="1">
                 <a:solidFill>
                   <a:srgbClr val="0F172A"/>
                 </a:solidFill>
@@ -3449,7 +3449,7 @@
               </a:defRPr>
             </a:pPr>
             <a:r>
-              <a:t>10 AI Agents</a:t>
+              <a:t>Codex AI Engine</a:t>
             </a:r>
           </a:p>
           <a:p>
@@ -3465,7 +3465,7 @@
               </a:defRPr>
             </a:pPr>
             <a:r>
-              <a:t>Decoupled execution graph for invoice, ledger &amp; tax audits</a:t>
+              <a:t>Advanced code-grade intelligence for Vision OCR invoice parsing &amp; rule reasoning</a:t>
             </a:r>
           </a:p>
         </p:txBody>
@@ -3624,7 +3624,7 @@
           <a:lstStyle/>
           <a:p>
             <a:pPr>
-              <a:defRPr sz="1800" b="1">
+              <a:defRPr sz="1700" b="1">
                 <a:solidFill>
                   <a:srgbClr val="0F172A"/>
                 </a:solidFill>
@@ -3632,7 +3632,7 @@
               </a:defRPr>
             </a:pPr>
             <a:r>
-              <a:t>22 ORM Models</a:t>
+              <a:t>Double-Entry Core Engine</a:t>
             </a:r>
           </a:p>
           <a:p>
@@ -3648,7 +3648,7 @@
               </a:defRPr>
             </a:pPr>
             <a:r>
-              <a:t>Immutable double-entry schema with complete audit logs</a:t>
+              <a:t>Mathematical equality enforcement ensuring $Total\ Debits = Total\ Credits$</a:t>
             </a:r>
           </a:p>
         </p:txBody>
@@ -3807,7 +3807,7 @@
           <a:lstStyle/>
           <a:p>
             <a:pPr>
-              <a:defRPr sz="1800" b="1">
+              <a:defRPr sz="1700" b="1">
                 <a:solidFill>
                   <a:srgbClr val="0F172A"/>
                 </a:solidFill>
@@ -3815,7 +3815,7 @@
               </a:defRPr>
             </a:pPr>
             <a:r>
-              <a:t>Google Gemini 2.5</a:t>
+              <a:t>Hybrid Cloud Infrastructure</a:t>
             </a:r>
           </a:p>
           <a:p>
@@ -3831,7 +3831,7 @@
               </a:defRPr>
             </a:pPr>
             <a:r>
-              <a:t>Vision OCR extraction &amp; RAG financial query copilot</a:t>
+              <a:t>Supabase Central DB + Client Device Storage + Vercel &amp; Render</a:t>
             </a:r>
           </a:p>
         </p:txBody>
@@ -3971,7 +3971,7 @@
               </a:defRPr>
             </a:pPr>
             <a:r>
-              <a:t>The Problem: Broken Manual Bookkeeping &amp; Statutory Risk</a:t>
+              <a:t>The Current Problem: Manual Accounting &amp; Tax Risks</a:t>
             </a:r>
           </a:p>
           <a:p>
@@ -3984,7 +3984,7 @@
               </a:defRPr>
             </a:pPr>
             <a:r>
-              <a:t>Operational inefficiencies faced by 63+ Million MSMEs in India</a:t>
+              <a:t>Operational bottlenecks faced by 63+ Million MSMEs in India</a:t>
             </a:r>
           </a:p>
         </p:txBody>
@@ -4039,7 +4039,7 @@
               </a:defRPr>
             </a:pPr>
             <a:r>
-              <a:t>[!] Critical Industry Warning: Manual invoice entry, un-tracked vendor TDS limits, and GSTR-2B discrepancies cause millions in lost tax credit and statutory audit notices.</a:t>
+              <a:t>[!] Critical Pain Point: Manual invoice entry, un-tracked vendor TDS limits, and GSTR-2B discrepancies cause millions in lost tax credit and statutory interest notices.</a:t>
             </a:r>
           </a:p>
         </p:txBody>
@@ -4206,7 +4206,7 @@
               </a:defRPr>
             </a:pPr>
             <a:r>
-              <a:t>100+ Hours Wasted Monthly</a:t>
+              <a:t>100+ Hours Lost to Manual Data Entry</a:t>
             </a:r>
           </a:p>
           <a:p>
@@ -4222,7 +4222,7 @@
               </a:defRPr>
             </a:pPr>
             <a:r>
-              <a:t>Accountants manually transcribe PDF bills and paper receipts line-by-line across disconnected spreadsheets, causing high human error rates.</a:t>
+              <a:t>Accountants manually transcribe PDF bills, physical receipts, and paper vouchers line-by-line across disconnected spreadsheets, causing high human error rates.</a:t>
             </a:r>
           </a:p>
         </p:txBody>
@@ -4389,7 +4389,7 @@
               </a:defRPr>
             </a:pPr>
             <a:r>
-              <a:t>GSTR-2B ITC Loss &amp; Interest Fines</a:t>
+              <a:t>18% GSTR-2B Input Tax Credit (ITC) Loss</a:t>
             </a:r>
           </a:p>
           <a:p>
@@ -4405,7 +4405,7 @@
               </a:defRPr>
             </a:pPr>
             <a:r>
-              <a:t>Discrepancies between supplier filings and internal accounts result in 18% lost Input Tax Credit (ITC) and statutory interest penalties.</a:t>
+              <a:t>Discrepancies between supplier portal filings and internal ledger accounts result in lost Input Tax Credit (ITC) and costly statutory audit interest penalties.</a:t>
             </a:r>
           </a:p>
         </p:txBody>
@@ -4572,7 +4572,7 @@
               </a:defRPr>
             </a:pPr>
             <a:r>
-              <a:t>Complex TDS Limits &amp; Naive AI Risk</a:t>
+              <a:t>Complex Section 194C/194J TDS Thresholds</a:t>
             </a:r>
           </a:p>
           <a:p>
@@ -4588,7 +4588,7 @@
               </a:defRPr>
             </a:pPr>
             <a:r>
-              <a:t>Section 194C (1%/2%) &amp; Section 194J (10%) limits are missed across vendors. Standard LLMs hallucinate numbers and break debit=credit balance rules.</a:t>
+              <a:t>Cumulative vendor payment thresholds (Section 194C 1%/2% &amp; Section 194J 10%) are missed across suppliers. Naive LLMs hallucinate numbers and break debit=credit equality.</a:t>
             </a:r>
           </a:p>
         </p:txBody>
@@ -4728,7 +4728,7 @@
               </a:defRPr>
             </a:pPr>
             <a:r>
-              <a:t>The Solution: Four Pillars of Accounting Integrity</a:t>
+              <a:t>Our Approach: Four Pillars of Accounting Integrity</a:t>
             </a:r>
           </a:p>
           <a:p>
@@ -4741,7 +4741,7 @@
               </a:defRPr>
             </a:pPr>
             <a:r>
-              <a:t>Decoupled architecture bridging unstructured inputs with deterministic accounting cores</a:t>
+              <a:t>Bridging unstructured document inputs with deterministic accounting engines</a:t>
             </a:r>
           </a:p>
         </p:txBody>
@@ -4908,7 +4908,7 @@
               </a:defRPr>
             </a:pPr>
             <a:r>
-              <a:t>1. Vision OCR &amp; Gemini 2.5</a:t>
+              <a:t>1. Vision OCR &amp; Codex Engine</a:t>
             </a:r>
           </a:p>
           <a:p>
@@ -4940,7 +4940,7 @@
               </a:defRPr>
             </a:pPr>
             <a:r>
-              <a:t>• Google Gemini 2.5 Flash Vision engine</a:t>
+              <a:t>• Codex AI vision parsing architecture</a:t>
             </a:r>
           </a:p>
           <a:p>
@@ -4953,7 +4953,7 @@
               </a:defRPr>
             </a:pPr>
             <a:r>
-              <a:t>• SHA256 disk caching (0ms repeat latency)</a:t>
+              <a:t>• SHA256 document hashing (0ms repeat latency)</a:t>
             </a:r>
           </a:p>
           <a:p>
@@ -4966,7 +4966,7 @@
               </a:defRPr>
             </a:pPr>
             <a:r>
-              <a:t>• Auto-flags low-confidence (&lt;85%) fields</a:t>
+              <a:t>• Auto-flags low-confidence (&lt;85%) field extractions</a:t>
             </a:r>
           </a:p>
         </p:txBody>
@@ -5191,7 +5191,7 @@
               </a:defRPr>
             </a:pPr>
             <a:r>
-              <a:t>• Cryptographic immutable transaction logs</a:t>
+              <a:t>• Cryptographic immutable transaction log</a:t>
             </a:r>
           </a:p>
         </p:txBody>
@@ -5416,7 +5416,7 @@
               </a:defRPr>
             </a:pPr>
             <a:r>
-              <a:t>• Audit trail logs every reviewer action</a:t>
+              <a:t>• Complete audit trail logs every reviewer action</a:t>
             </a:r>
           </a:p>
         </p:txBody>
@@ -5722,7 +5722,7 @@
             <a:avLst/>
           </a:prstGeom>
           <a:solidFill>
-            <a:srgbClr val="10B981"/>
+            <a:srgbClr val="2563EB"/>
           </a:solidFill>
           <a:ln>
             <a:noFill/>
@@ -5781,7 +5781,7 @@
               </a:defRPr>
             </a:pPr>
             <a:r>
-              <a:t>The Golden Path Workflow</a:t>
+              <a:t>AI Integration &amp; Codex Task Engine</a:t>
             </a:r>
           </a:p>
           <a:p>
@@ -5794,7 +5794,7 @@
               </a:defRPr>
             </a:pPr>
             <a:r>
-              <a:t>End-to-End PDF Document Ingestion to Immutable Ledger Commit</a:t>
+              <a:t>Combining OpenAI Codex Architecture with 1-Tap Financial Analysis</a:t>
             </a:r>
           </a:p>
         </p:txBody>
@@ -5808,7 +5808,7 @@
         <p:spPr>
           <a:xfrm>
             <a:off x="768096" y="1499616"/>
-            <a:ext cx="2514600" cy="4937760"/>
+            <a:ext cx="5212080" cy="2331720"/>
           </a:xfrm>
           <a:prstGeom prst="roundRect">
             <a:avLst/>
@@ -5851,7 +5851,7 @@
         <p:spPr>
           <a:xfrm>
             <a:off x="731520" y="1463040"/>
-            <a:ext cx="2514600" cy="4937760"/>
+            <a:ext cx="5212080" cy="2331720"/>
           </a:xfrm>
           <a:prstGeom prst="roundRect">
             <a:avLst/>
@@ -5889,20 +5889,20 @@
       </p:sp>
       <p:sp>
         <p:nvSpPr>
-          <p:cNvPr id="7" name="Oval 6"/>
+          <p:cNvPr id="7" name="Rectangle 6"/>
           <p:cNvSpPr/>
           <p:nvPr/>
         </p:nvSpPr>
         <p:spPr>
           <a:xfrm>
-            <a:off x="1691640" y="1645920"/>
-            <a:ext cx="594360" cy="594360"/>
-          </a:xfrm>
-          <a:prstGeom prst="ellipse">
-            <a:avLst/>
-          </a:prstGeom>
-          <a:solidFill>
-            <a:srgbClr val="10B981"/>
+            <a:off x="731520" y="1463040"/>
+            <a:ext cx="50800" cy="2331720"/>
+          </a:xfrm>
+          <a:prstGeom prst="rect">
+            <a:avLst/>
+          </a:prstGeom>
+          <a:solidFill>
+            <a:srgbClr val="2563EB"/>
           </a:solidFill>
           <a:ln>
             <a:noFill/>
@@ -5938,43 +5938,8 @@
         </p:nvSpPr>
         <p:spPr>
           <a:xfrm>
-            <a:off x="1691640" y="1645920"/>
-            <a:ext cx="594360" cy="594360"/>
-          </a:xfrm>
-          <a:prstGeom prst="rect">
-            <a:avLst/>
-          </a:prstGeom>
-          <a:noFill/>
-        </p:spPr>
-        <p:txBody>
-          <a:bodyPr wrap="none">
-            <a:spAutoFit/>
-          </a:bodyPr>
-          <a:lstStyle/>
-          <a:p>
-            <a:pPr algn="ctr">
-              <a:defRPr sz="1400" b="1">
-                <a:solidFill>
-                  <a:srgbClr val="FFFFFF"/>
-                </a:solidFill>
-              </a:defRPr>
-            </a:pPr>
-            <a:r>
-              <a:t>1</a:t>
-            </a:r>
-          </a:p>
-        </p:txBody>
-      </p:sp>
-      <p:sp>
-        <p:nvSpPr>
-          <p:cNvPr id="9" name="TextBox 8"/>
-          <p:cNvSpPr txBox="1"/>
-          <p:nvPr/>
-        </p:nvSpPr>
-        <p:spPr>
-          <a:xfrm>
-            <a:off x="914400" y="2331720"/>
-            <a:ext cx="2148840" cy="3931920"/>
+            <a:off x="1005840" y="1645920"/>
+            <a:ext cx="4663440" cy="1965960"/>
           </a:xfrm>
           <a:prstGeom prst="rect">
             <a:avLst/>
@@ -5988,7 +5953,7 @@
           <a:lstStyle/>
           <a:p>
             <a:pPr>
-              <a:defRPr sz="1400" b="1">
+              <a:defRPr sz="1500" b="1">
                 <a:solidFill>
                   <a:srgbClr val="0F172A"/>
                 </a:solidFill>
@@ -5996,88 +5961,37 @@
               </a:defRPr>
             </a:pPr>
             <a:r>
-              <a:t>Step 1: Upload</a:t>
+              <a:t>Codex AI Vision OCR</a:t>
             </a:r>
           </a:p>
           <a:p>
             <a:pPr>
               <a:spcBef>
-                <a:spcPts val="200"/>
+                <a:spcPts val="800"/>
               </a:spcBef>
-              <a:spcAft>
-                <a:spcPts val="800"/>
-              </a:spcAft>
-              <a:defRPr sz="1100" b="1">
-                <a:solidFill>
-                  <a:srgbClr val="10B981"/>
+              <a:defRPr sz="1100">
+                <a:solidFill>
+                  <a:srgbClr val="64748B"/>
                 </a:solidFill>
                 <a:latin typeface="Inter"/>
               </a:defRPr>
             </a:pPr>
             <a:r>
-              <a:t>Ingest PDF / Image</a:t>
-            </a:r>
-          </a:p>
-          <a:p>
-            <a:pPr>
-              <a:spcBef>
-                <a:spcPts val="400"/>
-              </a:spcBef>
-              <a:defRPr sz="1000">
-                <a:solidFill>
-                  <a:srgbClr val="64748B"/>
-                </a:solidFill>
-                <a:latin typeface="Inter"/>
-              </a:defRPr>
-            </a:pPr>
-            <a:r>
-              <a:t>• User drops PDF bill or receipt image</a:t>
-            </a:r>
-          </a:p>
-          <a:p>
-            <a:pPr>
-              <a:spcBef>
-                <a:spcPts val="400"/>
-              </a:spcBef>
-              <a:defRPr sz="1000">
-                <a:solidFill>
-                  <a:srgbClr val="64748B"/>
-                </a:solidFill>
-                <a:latin typeface="Inter"/>
-              </a:defRPr>
-            </a:pPr>
-            <a:r>
-              <a:t>• Generates unique SHA256 hash</a:t>
-            </a:r>
-          </a:p>
-          <a:p>
-            <a:pPr>
-              <a:spcBef>
-                <a:spcPts val="400"/>
-              </a:spcBef>
-              <a:defRPr sz="1000">
-                <a:solidFill>
-                  <a:srgbClr val="64748B"/>
-                </a:solidFill>
-                <a:latin typeface="Inter"/>
-              </a:defRPr>
-            </a:pPr>
-            <a:r>
-              <a:t>• Prevents duplicate invoice ingestion</a:t>
-            </a:r>
-          </a:p>
-        </p:txBody>
-      </p:sp>
-      <p:sp>
-        <p:nvSpPr>
-          <p:cNvPr id="10" name="Rounded Rectangle 9"/>
+              <a:t>Ingests PDF invoices, receipts, and image bills, extracting vendor name, GSTIN, line-item tax split, and grand totals with 99% accuracy.</a:t>
+            </a:r>
+          </a:p>
+        </p:txBody>
+      </p:sp>
+      <p:sp>
+        <p:nvSpPr>
+          <p:cNvPr id="9" name="Rounded Rectangle 8"/>
           <p:cNvSpPr/>
           <p:nvPr/>
         </p:nvSpPr>
         <p:spPr>
           <a:xfrm>
-            <a:off x="768098" y="1499616"/>
-            <a:ext cx="2514600" cy="4937760"/>
+            <a:off x="768102" y="1499616"/>
+            <a:ext cx="5212080" cy="2331720"/>
           </a:xfrm>
           <a:prstGeom prst="roundRect">
             <a:avLst/>
@@ -6113,14 +6027,14 @@
       </p:sp>
       <p:sp>
         <p:nvSpPr>
-          <p:cNvPr id="11" name="Rounded Rectangle 10"/>
+          <p:cNvPr id="10" name="Rounded Rectangle 9"/>
           <p:cNvSpPr/>
           <p:nvPr/>
         </p:nvSpPr>
         <p:spPr>
           <a:xfrm>
-            <a:off x="731522" y="1463040"/>
-            <a:ext cx="2514600" cy="4937760"/>
+            <a:off x="731526" y="1463040"/>
+            <a:ext cx="5212080" cy="2331720"/>
           </a:xfrm>
           <a:prstGeom prst="roundRect">
             <a:avLst/>
@@ -6158,20 +6072,20 @@
       </p:sp>
       <p:sp>
         <p:nvSpPr>
-          <p:cNvPr id="12" name="Oval 11"/>
+          <p:cNvPr id="11" name="Rectangle 10"/>
           <p:cNvSpPr/>
           <p:nvPr/>
         </p:nvSpPr>
         <p:spPr>
           <a:xfrm>
-            <a:off x="1691642" y="1645920"/>
-            <a:ext cx="594360" cy="594360"/>
-          </a:xfrm>
-          <a:prstGeom prst="ellipse">
-            <a:avLst/>
-          </a:prstGeom>
-          <a:solidFill>
-            <a:srgbClr val="10B981"/>
+            <a:off x="731526" y="1463040"/>
+            <a:ext cx="50800" cy="2331720"/>
+          </a:xfrm>
+          <a:prstGeom prst="rect">
+            <a:avLst/>
+          </a:prstGeom>
+          <a:solidFill>
+            <a:srgbClr val="2563EB"/>
           </a:solidFill>
           <a:ln>
             <a:noFill/>
@@ -6201,49 +6115,14 @@
       </p:sp>
       <p:sp>
         <p:nvSpPr>
-          <p:cNvPr id="13" name="TextBox 12"/>
+          <p:cNvPr id="12" name="TextBox 11"/>
           <p:cNvSpPr txBox="1"/>
           <p:nvPr/>
         </p:nvSpPr>
         <p:spPr>
           <a:xfrm>
-            <a:off x="1691642" y="1645920"/>
-            <a:ext cx="594360" cy="594360"/>
-          </a:xfrm>
-          <a:prstGeom prst="rect">
-            <a:avLst/>
-          </a:prstGeom>
-          <a:noFill/>
-        </p:spPr>
-        <p:txBody>
-          <a:bodyPr wrap="none">
-            <a:spAutoFit/>
-          </a:bodyPr>
-          <a:lstStyle/>
-          <a:p>
-            <a:pPr algn="ctr">
-              <a:defRPr sz="1400" b="1">
-                <a:solidFill>
-                  <a:srgbClr val="FFFFFF"/>
-                </a:solidFill>
-              </a:defRPr>
-            </a:pPr>
-            <a:r>
-              <a:t>2</a:t>
-            </a:r>
-          </a:p>
-        </p:txBody>
-      </p:sp>
-      <p:sp>
-        <p:nvSpPr>
-          <p:cNvPr id="14" name="TextBox 13"/>
-          <p:cNvSpPr txBox="1"/>
-          <p:nvPr/>
-        </p:nvSpPr>
-        <p:spPr>
-          <a:xfrm>
-            <a:off x="914402" y="2331720"/>
-            <a:ext cx="2148840" cy="3931920"/>
+            <a:off x="1005846" y="1645920"/>
+            <a:ext cx="4663440" cy="1965960"/>
           </a:xfrm>
           <a:prstGeom prst="rect">
             <a:avLst/>
@@ -6257,7 +6136,7 @@
           <a:lstStyle/>
           <a:p>
             <a:pPr>
-              <a:defRPr sz="1400" b="1">
+              <a:defRPr sz="1500" b="1">
                 <a:solidFill>
                   <a:srgbClr val="0F172A"/>
                 </a:solidFill>
@@ -6265,88 +6144,37 @@
               </a:defRPr>
             </a:pPr>
             <a:r>
-              <a:t>Step 2: AI Parse</a:t>
+              <a:t>Pre-Coded AI Task Shortcuts</a:t>
             </a:r>
           </a:p>
           <a:p>
             <a:pPr>
               <a:spcBef>
-                <a:spcPts val="200"/>
+                <a:spcPts val="800"/>
               </a:spcBef>
-              <a:spcAft>
-                <a:spcPts val="800"/>
-              </a:spcAft>
-              <a:defRPr sz="1100" b="1">
-                <a:solidFill>
-                  <a:srgbClr val="10B981"/>
+              <a:defRPr sz="1100">
+                <a:solidFill>
+                  <a:srgbClr val="64748B"/>
                 </a:solidFill>
                 <a:latin typeface="Inter"/>
               </a:defRPr>
             </a:pPr>
             <a:r>
-              <a:t>Extract &amp; Audit Tax</a:t>
-            </a:r>
-          </a:p>
-          <a:p>
-            <a:pPr>
-              <a:spcBef>
-                <a:spcPts val="400"/>
-              </a:spcBef>
-              <a:defRPr sz="1000">
-                <a:solidFill>
-                  <a:srgbClr val="64748B"/>
-                </a:solidFill>
-                <a:latin typeface="Inter"/>
-              </a:defRPr>
-            </a:pPr>
-            <a:r>
-              <a:t>• Gemini 2.5 Flash extracts fields</a:t>
-            </a:r>
-          </a:p>
-          <a:p>
-            <a:pPr>
-              <a:spcBef>
-                <a:spcPts val="400"/>
-              </a:spcBef>
-              <a:defRPr sz="1000">
-                <a:solidFill>
-                  <a:srgbClr val="64748B"/>
-                </a:solidFill>
-                <a:latin typeface="Inter"/>
-              </a:defRPr>
-            </a:pPr>
-            <a:r>
-              <a:t>• GST Agent validates 15-char GSTIN</a:t>
-            </a:r>
-          </a:p>
-          <a:p>
-            <a:pPr>
-              <a:spcBef>
-                <a:spcPts val="400"/>
-              </a:spcBef>
-              <a:defRPr sz="1000">
-                <a:solidFill>
-                  <a:srgbClr val="64748B"/>
-                </a:solidFill>
-                <a:latin typeface="Inter"/>
-              </a:defRPr>
-            </a:pPr>
-            <a:r>
-              <a:t>• Verifies GSTR-2B ITC eligibility</a:t>
-            </a:r>
-          </a:p>
-        </p:txBody>
-      </p:sp>
-      <p:sp>
-        <p:nvSpPr>
-          <p:cNvPr id="15" name="Rounded Rectangle 14"/>
+              <a:t>1-tap task triggers: Audit GSTR-2B ITC, Check Trial Balance Equality, Calculate Section 194C/194J Limits, Reconcile Bank Feed, P&amp;L Highlights.</a:t>
+            </a:r>
+          </a:p>
+        </p:txBody>
+      </p:sp>
+      <p:sp>
+        <p:nvSpPr>
+          <p:cNvPr id="13" name="Rounded Rectangle 12"/>
           <p:cNvSpPr/>
           <p:nvPr/>
         </p:nvSpPr>
         <p:spPr>
           <a:xfrm>
-            <a:off x="768101" y="1499616"/>
-            <a:ext cx="2514600" cy="4937760"/>
+            <a:off x="768096" y="1499618"/>
+            <a:ext cx="5212080" cy="2331720"/>
           </a:xfrm>
           <a:prstGeom prst="roundRect">
             <a:avLst/>
@@ -6382,14 +6210,14 @@
       </p:sp>
       <p:sp>
         <p:nvSpPr>
-          <p:cNvPr id="16" name="Rounded Rectangle 15"/>
+          <p:cNvPr id="14" name="Rounded Rectangle 13"/>
           <p:cNvSpPr/>
           <p:nvPr/>
         </p:nvSpPr>
         <p:spPr>
           <a:xfrm>
-            <a:off x="731525" y="1463040"/>
-            <a:ext cx="2514600" cy="4937760"/>
+            <a:off x="731520" y="1463042"/>
+            <a:ext cx="5212080" cy="2331720"/>
           </a:xfrm>
           <a:prstGeom prst="roundRect">
             <a:avLst/>
@@ -6427,20 +6255,20 @@
       </p:sp>
       <p:sp>
         <p:nvSpPr>
-          <p:cNvPr id="17" name="Oval 16"/>
+          <p:cNvPr id="15" name="Rectangle 14"/>
           <p:cNvSpPr/>
           <p:nvPr/>
         </p:nvSpPr>
         <p:spPr>
           <a:xfrm>
-            <a:off x="1691645" y="1645920"/>
-            <a:ext cx="594360" cy="594360"/>
-          </a:xfrm>
-          <a:prstGeom prst="ellipse">
-            <a:avLst/>
-          </a:prstGeom>
-          <a:solidFill>
-            <a:srgbClr val="10B981"/>
+            <a:off x="731520" y="1463042"/>
+            <a:ext cx="50800" cy="2331720"/>
+          </a:xfrm>
+          <a:prstGeom prst="rect">
+            <a:avLst/>
+          </a:prstGeom>
+          <a:solidFill>
+            <a:srgbClr val="2563EB"/>
           </a:solidFill>
           <a:ln>
             <a:noFill/>
@@ -6470,49 +6298,14 @@
       </p:sp>
       <p:sp>
         <p:nvSpPr>
-          <p:cNvPr id="18" name="TextBox 17"/>
+          <p:cNvPr id="16" name="TextBox 15"/>
           <p:cNvSpPr txBox="1"/>
           <p:nvPr/>
         </p:nvSpPr>
         <p:spPr>
           <a:xfrm>
-            <a:off x="1691645" y="1645920"/>
-            <a:ext cx="594360" cy="594360"/>
-          </a:xfrm>
-          <a:prstGeom prst="rect">
-            <a:avLst/>
-          </a:prstGeom>
-          <a:noFill/>
-        </p:spPr>
-        <p:txBody>
-          <a:bodyPr wrap="none">
-            <a:spAutoFit/>
-          </a:bodyPr>
-          <a:lstStyle/>
-          <a:p>
-            <a:pPr algn="ctr">
-              <a:defRPr sz="1400" b="1">
-                <a:solidFill>
-                  <a:srgbClr val="FFFFFF"/>
-                </a:solidFill>
-              </a:defRPr>
-            </a:pPr>
-            <a:r>
-              <a:t>3</a:t>
-            </a:r>
-          </a:p>
-        </p:txBody>
-      </p:sp>
-      <p:sp>
-        <p:nvSpPr>
-          <p:cNvPr id="19" name="TextBox 18"/>
-          <p:cNvSpPr txBox="1"/>
-          <p:nvPr/>
-        </p:nvSpPr>
-        <p:spPr>
-          <a:xfrm>
-            <a:off x="914405" y="2331720"/>
-            <a:ext cx="2148840" cy="3931920"/>
+            <a:off x="1005840" y="1645922"/>
+            <a:ext cx="4663440" cy="1965960"/>
           </a:xfrm>
           <a:prstGeom prst="rect">
             <a:avLst/>
@@ -6526,7 +6319,7 @@
           <a:lstStyle/>
           <a:p>
             <a:pPr>
-              <a:defRPr sz="1400" b="1">
+              <a:defRPr sz="1500" b="1">
                 <a:solidFill>
                   <a:srgbClr val="0F172A"/>
                 </a:solidFill>
@@ -6534,88 +6327,37 @@
               </a:defRPr>
             </a:pPr>
             <a:r>
-              <a:t>Step 3: Human Review</a:t>
+              <a:t>Automated Compliance Rules</a:t>
             </a:r>
           </a:p>
           <a:p>
             <a:pPr>
               <a:spcBef>
-                <a:spcPts val="200"/>
+                <a:spcPts val="800"/>
               </a:spcBef>
-              <a:spcAft>
-                <a:spcPts val="800"/>
-              </a:spcAft>
-              <a:defRPr sz="1100" b="1">
-                <a:solidFill>
-                  <a:srgbClr val="10B981"/>
+              <a:defRPr sz="1100">
+                <a:solidFill>
+                  <a:srgbClr val="64748B"/>
                 </a:solidFill>
                 <a:latin typeface="Inter"/>
               </a:defRPr>
             </a:pPr>
             <a:r>
-              <a:t>CA Signoff Checkpoint</a:t>
-            </a:r>
-          </a:p>
-          <a:p>
-            <a:pPr>
-              <a:spcBef>
-                <a:spcPts val="400"/>
-              </a:spcBef>
-              <a:defRPr sz="1000">
-                <a:solidFill>
-                  <a:srgbClr val="64748B"/>
-                </a:solidFill>
-                <a:latin typeface="Inter"/>
-              </a:defRPr>
-            </a:pPr>
-            <a:r>
-              <a:t>• Split-screen PDF viewer + journal</a:t>
-            </a:r>
-          </a:p>
-          <a:p>
-            <a:pPr>
-              <a:spcBef>
-                <a:spcPts val="400"/>
-              </a:spcBef>
-              <a:defRPr sz="1000">
-                <a:solidFill>
-                  <a:srgbClr val="64748B"/>
-                </a:solidFill>
-                <a:latin typeface="Inter"/>
-              </a:defRPr>
-            </a:pPr>
-            <a:r>
-              <a:t>• Validates $Dr. Exp + Dr. Tax = Cr. AP$</a:t>
-            </a:r>
-          </a:p>
-          <a:p>
-            <a:pPr>
-              <a:spcBef>
-                <a:spcPts val="400"/>
-              </a:spcBef>
-              <a:defRPr sz="1000">
-                <a:solidFill>
-                  <a:srgbClr val="64748B"/>
-                </a:solidFill>
-                <a:latin typeface="Inter"/>
-              </a:defRPr>
-            </a:pPr>
-            <a:r>
-              <a:t>• 1-click approve or reject with comments</a:t>
-            </a:r>
-          </a:p>
-        </p:txBody>
-      </p:sp>
-      <p:sp>
-        <p:nvSpPr>
-          <p:cNvPr id="20" name="Rounded Rectangle 19"/>
+              <a:t>Executes 15-char GSTIN syntax verification, duplicate SHA256 document detection, and double-entry mathematical constraint checks.</a:t>
+            </a:r>
+          </a:p>
+        </p:txBody>
+      </p:sp>
+      <p:sp>
+        <p:nvSpPr>
+          <p:cNvPr id="17" name="Rounded Rectangle 16"/>
           <p:cNvSpPr/>
           <p:nvPr/>
         </p:nvSpPr>
         <p:spPr>
           <a:xfrm>
-            <a:off x="768104" y="1499616"/>
-            <a:ext cx="2514600" cy="4937760"/>
+            <a:off x="768102" y="1499618"/>
+            <a:ext cx="5212080" cy="2331720"/>
           </a:xfrm>
           <a:prstGeom prst="roundRect">
             <a:avLst/>
@@ -6651,14 +6393,14 @@
       </p:sp>
       <p:sp>
         <p:nvSpPr>
-          <p:cNvPr id="21" name="Rounded Rectangle 20"/>
+          <p:cNvPr id="18" name="Rounded Rectangle 17"/>
           <p:cNvSpPr/>
           <p:nvPr/>
         </p:nvSpPr>
         <p:spPr>
           <a:xfrm>
-            <a:off x="731528" y="1463040"/>
-            <a:ext cx="2514600" cy="4937760"/>
+            <a:off x="731526" y="1463042"/>
+            <a:ext cx="5212080" cy="2331720"/>
           </a:xfrm>
           <a:prstGeom prst="roundRect">
             <a:avLst/>
@@ -6696,20 +6438,20 @@
       </p:sp>
       <p:sp>
         <p:nvSpPr>
-          <p:cNvPr id="22" name="Oval 21"/>
+          <p:cNvPr id="19" name="Rectangle 18"/>
           <p:cNvSpPr/>
           <p:nvPr/>
         </p:nvSpPr>
         <p:spPr>
           <a:xfrm>
-            <a:off x="1691648" y="1645920"/>
-            <a:ext cx="594360" cy="594360"/>
-          </a:xfrm>
-          <a:prstGeom prst="ellipse">
-            <a:avLst/>
-          </a:prstGeom>
-          <a:solidFill>
-            <a:srgbClr val="10B981"/>
+            <a:off x="731526" y="1463042"/>
+            <a:ext cx="50800" cy="2331720"/>
+          </a:xfrm>
+          <a:prstGeom prst="rect">
+            <a:avLst/>
+          </a:prstGeom>
+          <a:solidFill>
+            <a:srgbClr val="2563EB"/>
           </a:solidFill>
           <a:ln>
             <a:noFill/>
@@ -6739,49 +6481,14 @@
       </p:sp>
       <p:sp>
         <p:nvSpPr>
-          <p:cNvPr id="23" name="TextBox 22"/>
+          <p:cNvPr id="20" name="TextBox 19"/>
           <p:cNvSpPr txBox="1"/>
           <p:nvPr/>
         </p:nvSpPr>
         <p:spPr>
           <a:xfrm>
-            <a:off x="1691648" y="1645920"/>
-            <a:ext cx="594360" cy="594360"/>
-          </a:xfrm>
-          <a:prstGeom prst="rect">
-            <a:avLst/>
-          </a:prstGeom>
-          <a:noFill/>
-        </p:spPr>
-        <p:txBody>
-          <a:bodyPr wrap="none">
-            <a:spAutoFit/>
-          </a:bodyPr>
-          <a:lstStyle/>
-          <a:p>
-            <a:pPr algn="ctr">
-              <a:defRPr sz="1400" b="1">
-                <a:solidFill>
-                  <a:srgbClr val="FFFFFF"/>
-                </a:solidFill>
-              </a:defRPr>
-            </a:pPr>
-            <a:r>
-              <a:t>4</a:t>
-            </a:r>
-          </a:p>
-        </p:txBody>
-      </p:sp>
-      <p:sp>
-        <p:nvSpPr>
-          <p:cNvPr id="24" name="TextBox 23"/>
-          <p:cNvSpPr txBox="1"/>
-          <p:nvPr/>
-        </p:nvSpPr>
-        <p:spPr>
-          <a:xfrm>
-            <a:off x="914408" y="2331720"/>
-            <a:ext cx="2148840" cy="3931920"/>
+            <a:off x="1005846" y="1645922"/>
+            <a:ext cx="4663440" cy="1965960"/>
           </a:xfrm>
           <a:prstGeom prst="rect">
             <a:avLst/>
@@ -6795,7 +6502,7 @@
           <a:lstStyle/>
           <a:p>
             <a:pPr>
-              <a:defRPr sz="1400" b="1">
+              <a:defRPr sz="1500" b="1">
                 <a:solidFill>
                   <a:srgbClr val="0F172A"/>
                 </a:solidFill>
@@ -6803,74 +6510,23 @@
               </a:defRPr>
             </a:pPr>
             <a:r>
-              <a:t>Step 4: Commit</a:t>
+              <a:t>Natural Language Financial Query</a:t>
             </a:r>
           </a:p>
           <a:p>
             <a:pPr>
               <a:spcBef>
-                <a:spcPts val="200"/>
+                <a:spcPts val="800"/>
               </a:spcBef>
-              <a:spcAft>
-                <a:spcPts val="800"/>
-              </a:spcAft>
-              <a:defRPr sz="1100" b="1">
-                <a:solidFill>
-                  <a:srgbClr val="10B981"/>
+              <a:defRPr sz="1100">
+                <a:solidFill>
+                  <a:srgbClr val="64748B"/>
                 </a:solidFill>
                 <a:latin typeface="Inter"/>
               </a:defRPr>
             </a:pPr>
             <a:r>
-              <a:t>Immutable Ledger</a:t>
-            </a:r>
-          </a:p>
-          <a:p>
-            <a:pPr>
-              <a:spcBef>
-                <a:spcPts val="400"/>
-              </a:spcBef>
-              <a:defRPr sz="1000">
-                <a:solidFill>
-                  <a:srgbClr val="64748B"/>
-                </a:solidFill>
-                <a:latin typeface="Inter"/>
-              </a:defRPr>
-            </a:pPr>
-            <a:r>
-              <a:t>• Double-entry posted to database</a:t>
-            </a:r>
-          </a:p>
-          <a:p>
-            <a:pPr>
-              <a:spcBef>
-                <a:spcPts val="400"/>
-              </a:spcBef>
-              <a:defRPr sz="1000">
-                <a:solidFill>
-                  <a:srgbClr val="64748B"/>
-                </a:solidFill>
-                <a:latin typeface="Inter"/>
-              </a:defRPr>
-            </a:pPr>
-            <a:r>
-              <a:t>• Journal marked immutable</a:t>
-            </a:r>
-          </a:p>
-          <a:p>
-            <a:pPr>
-              <a:spcBef>
-                <a:spcPts val="400"/>
-              </a:spcBef>
-              <a:defRPr sz="1000">
-                <a:solidFill>
-                  <a:srgbClr val="64748B"/>
-                </a:solidFill>
-                <a:latin typeface="Inter"/>
-              </a:defRPr>
-            </a:pPr>
-            <a:r>
-              <a:t>• P&amp;L and Balance Sheet update live</a:t>
+              <a:t>Interactive AI Copilot allowing Chartered Accountants to query cash runway, un-posted vouchers, and tax return filing deadlines.</a:t>
             </a:r>
           </a:p>
         </p:txBody>
@@ -6951,7 +6607,7 @@
             <a:avLst/>
           </a:prstGeom>
           <a:solidFill>
-            <a:srgbClr val="4338CA"/>
+            <a:srgbClr val="10B981"/>
           </a:solidFill>
           <a:ln>
             <a:noFill/>
@@ -7010,7 +6666,7 @@
               </a:defRPr>
             </a:pPr>
             <a:r>
-              <a:t>Production-Grade System Architecture</a:t>
+              <a:t>The Golden Path Workflow</a:t>
             </a:r>
           </a:p>
           <a:p>
@@ -7023,7 +6679,7 @@
               </a:defRPr>
             </a:pPr>
             <a:r>
-              <a:t>Decoupled full-stack SaaS platform built with FastAPI, React 18 &amp; Google Gemini 2.5</a:t>
+              <a:t>End-to-End Ingestion, AI Parsing, CA Signoff &amp; Immutable Ledger Commit</a:t>
             </a:r>
           </a:p>
         </p:txBody>
@@ -7036,8 +6692,8 @@
         </p:nvSpPr>
         <p:spPr>
           <a:xfrm>
-            <a:off x="768096" y="1453896"/>
-            <a:ext cx="10725912" cy="1115568"/>
+            <a:off x="768096" y="1499616"/>
+            <a:ext cx="2514600" cy="4937760"/>
           </a:xfrm>
           <a:prstGeom prst="roundRect">
             <a:avLst/>
@@ -7079,8 +6735,8 @@
         </p:nvSpPr>
         <p:spPr>
           <a:xfrm>
-            <a:off x="731520" y="1417320"/>
-            <a:ext cx="10725912" cy="1115568"/>
+            <a:off x="731520" y="1463040"/>
+            <a:ext cx="2514600" cy="4937760"/>
           </a:xfrm>
           <a:prstGeom prst="roundRect">
             <a:avLst/>
@@ -7118,20 +6774,20 @@
       </p:sp>
       <p:sp>
         <p:nvSpPr>
-          <p:cNvPr id="7" name="Rectangle 6"/>
+          <p:cNvPr id="7" name="Oval 6"/>
           <p:cNvSpPr/>
           <p:nvPr/>
         </p:nvSpPr>
         <p:spPr>
           <a:xfrm>
-            <a:off x="731520" y="1417320"/>
-            <a:ext cx="50800" cy="1115568"/>
-          </a:xfrm>
-          <a:prstGeom prst="rect">
-            <a:avLst/>
-          </a:prstGeom>
-          <a:solidFill>
-            <a:srgbClr val="4338CA"/>
+            <a:off x="1691640" y="1645920"/>
+            <a:ext cx="594360" cy="594360"/>
+          </a:xfrm>
+          <a:prstGeom prst="ellipse">
+            <a:avLst/>
+          </a:prstGeom>
+          <a:solidFill>
+            <a:srgbClr val="10B981"/>
           </a:solidFill>
           <a:ln>
             <a:noFill/>
@@ -7167,8 +6823,43 @@
         </p:nvSpPr>
         <p:spPr>
           <a:xfrm>
-            <a:off x="1005840" y="1527048"/>
-            <a:ext cx="10332720" cy="914400"/>
+            <a:off x="1691640" y="1645920"/>
+            <a:ext cx="594360" cy="594360"/>
+          </a:xfrm>
+          <a:prstGeom prst="rect">
+            <a:avLst/>
+          </a:prstGeom>
+          <a:noFill/>
+        </p:spPr>
+        <p:txBody>
+          <a:bodyPr wrap="none">
+            <a:spAutoFit/>
+          </a:bodyPr>
+          <a:lstStyle/>
+          <a:p>
+            <a:pPr algn="ctr">
+              <a:defRPr sz="1400" b="1">
+                <a:solidFill>
+                  <a:srgbClr val="FFFFFF"/>
+                </a:solidFill>
+              </a:defRPr>
+            </a:pPr>
+            <a:r>
+              <a:t>1</a:t>
+            </a:r>
+          </a:p>
+        </p:txBody>
+      </p:sp>
+      <p:sp>
+        <p:nvSpPr>
+          <p:cNvPr id="9" name="TextBox 8"/>
+          <p:cNvSpPr txBox="1"/>
+          <p:nvPr/>
+        </p:nvSpPr>
+        <p:spPr>
+          <a:xfrm>
+            <a:off x="914400" y="2331720"/>
+            <a:ext cx="2148840" cy="3931920"/>
           </a:xfrm>
           <a:prstGeom prst="rect">
             <a:avLst/>
@@ -7190,7 +6881,26 @@
               </a:defRPr>
             </a:pPr>
             <a:r>
-              <a:t>Client Tier (React 18 + Vite + Tailwind CSS)</a:t>
+              <a:t>Step 1: Upload</a:t>
+            </a:r>
+          </a:p>
+          <a:p>
+            <a:pPr>
+              <a:spcBef>
+                <a:spcPts val="200"/>
+              </a:spcBef>
+              <a:spcAft>
+                <a:spcPts val="800"/>
+              </a:spcAft>
+              <a:defRPr sz="1100" b="1">
+                <a:solidFill>
+                  <a:srgbClr val="10B981"/>
+                </a:solidFill>
+                <a:latin typeface="Inter"/>
+              </a:defRPr>
+            </a:pPr>
+            <a:r>
+              <a:t>Ingest PDF / Image</a:t>
             </a:r>
           </a:p>
           <a:p>
@@ -7198,7 +6908,7 @@
               <a:spcBef>
                 <a:spcPts val="400"/>
               </a:spcBef>
-              <a:defRPr sz="1100">
+              <a:defRPr sz="1000">
                 <a:solidFill>
                   <a:srgbClr val="64748B"/>
                 </a:solidFill>
@@ -7206,21 +6916,53 @@
               </a:defRPr>
             </a:pPr>
             <a:r>
-              <a:t>Light Grey &amp; Trust Blue Theme (#2563EB) • Interactive AppContext global state • Command Palette (Cmd+K) &amp; PDF Canvas Viewer • Real-time Agent Event Ticker</a:t>
-            </a:r>
-          </a:p>
-        </p:txBody>
-      </p:sp>
-      <p:sp>
-        <p:nvSpPr>
-          <p:cNvPr id="9" name="Rounded Rectangle 8"/>
+              <a:t>• User drops PDF bill or receipt image</a:t>
+            </a:r>
+          </a:p>
+          <a:p>
+            <a:pPr>
+              <a:spcBef>
+                <a:spcPts val="400"/>
+              </a:spcBef>
+              <a:defRPr sz="1000">
+                <a:solidFill>
+                  <a:srgbClr val="64748B"/>
+                </a:solidFill>
+                <a:latin typeface="Inter"/>
+              </a:defRPr>
+            </a:pPr>
+            <a:r>
+              <a:t>• Generates unique SHA256 hash</a:t>
+            </a:r>
+          </a:p>
+          <a:p>
+            <a:pPr>
+              <a:spcBef>
+                <a:spcPts val="400"/>
+              </a:spcBef>
+              <a:defRPr sz="1000">
+                <a:solidFill>
+                  <a:srgbClr val="64748B"/>
+                </a:solidFill>
+                <a:latin typeface="Inter"/>
+              </a:defRPr>
+            </a:pPr>
+            <a:r>
+              <a:t>• Prevents duplicate invoice ingestion</a:t>
+            </a:r>
+          </a:p>
+        </p:txBody>
+      </p:sp>
+      <p:sp>
+        <p:nvSpPr>
+          <p:cNvPr id="10" name="Rounded Rectangle 9"/>
           <p:cNvSpPr/>
           <p:nvPr/>
         </p:nvSpPr>
         <p:spPr>
           <a:xfrm>
-            <a:off x="768096" y="1453897"/>
-            <a:ext cx="10725912" cy="1115568"/>
+            <a:off x="768098" y="1499616"/>
+            <a:ext cx="2514600" cy="4937760"/>
           </a:xfrm>
           <a:prstGeom prst="roundRect">
             <a:avLst/>
@@ -7256,14 +6998,14 @@
       </p:sp>
       <p:sp>
         <p:nvSpPr>
-          <p:cNvPr id="10" name="Rounded Rectangle 9"/>
+          <p:cNvPr id="11" name="Rounded Rectangle 10"/>
           <p:cNvSpPr/>
           <p:nvPr/>
         </p:nvSpPr>
         <p:spPr>
           <a:xfrm>
-            <a:off x="731520" y="1417321"/>
-            <a:ext cx="10725912" cy="1115568"/>
+            <a:off x="731522" y="1463040"/>
+            <a:ext cx="2514600" cy="4937760"/>
           </a:xfrm>
           <a:prstGeom prst="roundRect">
             <a:avLst/>
@@ -7301,20 +7043,20 @@
       </p:sp>
       <p:sp>
         <p:nvSpPr>
-          <p:cNvPr id="11" name="Rectangle 10"/>
+          <p:cNvPr id="12" name="Oval 11"/>
           <p:cNvSpPr/>
           <p:nvPr/>
         </p:nvSpPr>
         <p:spPr>
           <a:xfrm>
-            <a:off x="731520" y="1417321"/>
-            <a:ext cx="50800" cy="1115568"/>
-          </a:xfrm>
-          <a:prstGeom prst="rect">
-            <a:avLst/>
-          </a:prstGeom>
-          <a:solidFill>
-            <a:srgbClr val="4338CA"/>
+            <a:off x="1691642" y="1645920"/>
+            <a:ext cx="594360" cy="594360"/>
+          </a:xfrm>
+          <a:prstGeom prst="ellipse">
+            <a:avLst/>
+          </a:prstGeom>
+          <a:solidFill>
+            <a:srgbClr val="10B981"/>
           </a:solidFill>
           <a:ln>
             <a:noFill/>
@@ -7344,14 +7086,49 @@
       </p:sp>
       <p:sp>
         <p:nvSpPr>
-          <p:cNvPr id="12" name="TextBox 11"/>
+          <p:cNvPr id="13" name="TextBox 12"/>
           <p:cNvSpPr txBox="1"/>
           <p:nvPr/>
         </p:nvSpPr>
         <p:spPr>
           <a:xfrm>
-            <a:off x="1005840" y="1527049"/>
-            <a:ext cx="10332720" cy="914400"/>
+            <a:off x="1691642" y="1645920"/>
+            <a:ext cx="594360" cy="594360"/>
+          </a:xfrm>
+          <a:prstGeom prst="rect">
+            <a:avLst/>
+          </a:prstGeom>
+          <a:noFill/>
+        </p:spPr>
+        <p:txBody>
+          <a:bodyPr wrap="none">
+            <a:spAutoFit/>
+          </a:bodyPr>
+          <a:lstStyle/>
+          <a:p>
+            <a:pPr algn="ctr">
+              <a:defRPr sz="1400" b="1">
+                <a:solidFill>
+                  <a:srgbClr val="FFFFFF"/>
+                </a:solidFill>
+              </a:defRPr>
+            </a:pPr>
+            <a:r>
+              <a:t>2</a:t>
+            </a:r>
+          </a:p>
+        </p:txBody>
+      </p:sp>
+      <p:sp>
+        <p:nvSpPr>
+          <p:cNvPr id="14" name="TextBox 13"/>
+          <p:cNvSpPr txBox="1"/>
+          <p:nvPr/>
+        </p:nvSpPr>
+        <p:spPr>
+          <a:xfrm>
+            <a:off x="914402" y="2331720"/>
+            <a:ext cx="2148840" cy="3931920"/>
           </a:xfrm>
           <a:prstGeom prst="rect">
             <a:avLst/>
@@ -7373,7 +7150,26 @@
               </a:defRPr>
             </a:pPr>
             <a:r>
-              <a:t>FastAPI Core Cluster (Python 3.11+)</a:t>
+              <a:t>Step 2: AI Parse</a:t>
+            </a:r>
+          </a:p>
+          <a:p>
+            <a:pPr>
+              <a:spcBef>
+                <a:spcPts val="200"/>
+              </a:spcBef>
+              <a:spcAft>
+                <a:spcPts val="800"/>
+              </a:spcAft>
+              <a:defRPr sz="1100" b="1">
+                <a:solidFill>
+                  <a:srgbClr val="10B981"/>
+                </a:solidFill>
+                <a:latin typeface="Inter"/>
+              </a:defRPr>
+            </a:pPr>
+            <a:r>
+              <a:t>Extract &amp; Audit Tax</a:t>
             </a:r>
           </a:p>
           <a:p>
@@ -7381,7 +7177,7 @@
               <a:spcBef>
                 <a:spcPts val="400"/>
               </a:spcBef>
-              <a:defRPr sz="1100">
+              <a:defRPr sz="1000">
                 <a:solidFill>
                   <a:srgbClr val="64748B"/>
                 </a:solidFill>
@@ -7389,21 +7185,53 @@
               </a:defRPr>
             </a:pPr>
             <a:r>
-              <a:t>Asynchronous REST API endpoints (/api/v1/invoices, /journals, /gst, /reports) • Real-time WebSockets streaming server (/ws/ai/stream) • Pydantic v2 data validation schemas</a:t>
-            </a:r>
-          </a:p>
-        </p:txBody>
-      </p:sp>
-      <p:sp>
-        <p:nvSpPr>
-          <p:cNvPr id="13" name="Rounded Rectangle 12"/>
+              <a:t>• Codex AI engine extracts fields</a:t>
+            </a:r>
+          </a:p>
+          <a:p>
+            <a:pPr>
+              <a:spcBef>
+                <a:spcPts val="400"/>
+              </a:spcBef>
+              <a:defRPr sz="1000">
+                <a:solidFill>
+                  <a:srgbClr val="64748B"/>
+                </a:solidFill>
+                <a:latin typeface="Inter"/>
+              </a:defRPr>
+            </a:pPr>
+            <a:r>
+              <a:t>• GST engine validates 15-char GSTIN</a:t>
+            </a:r>
+          </a:p>
+          <a:p>
+            <a:pPr>
+              <a:spcBef>
+                <a:spcPts val="400"/>
+              </a:spcBef>
+              <a:defRPr sz="1000">
+                <a:solidFill>
+                  <a:srgbClr val="64748B"/>
+                </a:solidFill>
+                <a:latin typeface="Inter"/>
+              </a:defRPr>
+            </a:pPr>
+            <a:r>
+              <a:t>• Verifies GSTR-2B ITC eligibility</a:t>
+            </a:r>
+          </a:p>
+        </p:txBody>
+      </p:sp>
+      <p:sp>
+        <p:nvSpPr>
+          <p:cNvPr id="15" name="Rounded Rectangle 14"/>
           <p:cNvSpPr/>
           <p:nvPr/>
         </p:nvSpPr>
         <p:spPr>
           <a:xfrm>
-            <a:off x="768096" y="1453898"/>
-            <a:ext cx="10725912" cy="1115568"/>
+            <a:off x="768101" y="1499616"/>
+            <a:ext cx="2514600" cy="4937760"/>
           </a:xfrm>
           <a:prstGeom prst="roundRect">
             <a:avLst/>
@@ -7439,14 +7267,14 @@
       </p:sp>
       <p:sp>
         <p:nvSpPr>
-          <p:cNvPr id="14" name="Rounded Rectangle 13"/>
+          <p:cNvPr id="16" name="Rounded Rectangle 15"/>
           <p:cNvSpPr/>
           <p:nvPr/>
         </p:nvSpPr>
         <p:spPr>
           <a:xfrm>
-            <a:off x="731520" y="1417322"/>
-            <a:ext cx="10725912" cy="1115568"/>
+            <a:off x="731525" y="1463040"/>
+            <a:ext cx="2514600" cy="4937760"/>
           </a:xfrm>
           <a:prstGeom prst="roundRect">
             <a:avLst/>
@@ -7484,20 +7312,20 @@
       </p:sp>
       <p:sp>
         <p:nvSpPr>
-          <p:cNvPr id="15" name="Rectangle 14"/>
+          <p:cNvPr id="17" name="Oval 16"/>
           <p:cNvSpPr/>
           <p:nvPr/>
         </p:nvSpPr>
         <p:spPr>
           <a:xfrm>
-            <a:off x="731520" y="1417322"/>
-            <a:ext cx="50800" cy="1115568"/>
-          </a:xfrm>
-          <a:prstGeom prst="rect">
-            <a:avLst/>
-          </a:prstGeom>
-          <a:solidFill>
-            <a:srgbClr val="4338CA"/>
+            <a:off x="1691645" y="1645920"/>
+            <a:ext cx="594360" cy="594360"/>
+          </a:xfrm>
+          <a:prstGeom prst="ellipse">
+            <a:avLst/>
+          </a:prstGeom>
+          <a:solidFill>
+            <a:srgbClr val="10B981"/>
           </a:solidFill>
           <a:ln>
             <a:noFill/>
@@ -7527,14 +7355,49 @@
       </p:sp>
       <p:sp>
         <p:nvSpPr>
-          <p:cNvPr id="16" name="TextBox 15"/>
+          <p:cNvPr id="18" name="TextBox 17"/>
           <p:cNvSpPr txBox="1"/>
           <p:nvPr/>
         </p:nvSpPr>
         <p:spPr>
           <a:xfrm>
-            <a:off x="1005840" y="1527050"/>
-            <a:ext cx="10332720" cy="914400"/>
+            <a:off x="1691645" y="1645920"/>
+            <a:ext cx="594360" cy="594360"/>
+          </a:xfrm>
+          <a:prstGeom prst="rect">
+            <a:avLst/>
+          </a:prstGeom>
+          <a:noFill/>
+        </p:spPr>
+        <p:txBody>
+          <a:bodyPr wrap="none">
+            <a:spAutoFit/>
+          </a:bodyPr>
+          <a:lstStyle/>
+          <a:p>
+            <a:pPr algn="ctr">
+              <a:defRPr sz="1400" b="1">
+                <a:solidFill>
+                  <a:srgbClr val="FFFFFF"/>
+                </a:solidFill>
+              </a:defRPr>
+            </a:pPr>
+            <a:r>
+              <a:t>3</a:t>
+            </a:r>
+          </a:p>
+        </p:txBody>
+      </p:sp>
+      <p:sp>
+        <p:nvSpPr>
+          <p:cNvPr id="19" name="TextBox 18"/>
+          <p:cNvSpPr txBox="1"/>
+          <p:nvPr/>
+        </p:nvSpPr>
+        <p:spPr>
+          <a:xfrm>
+            <a:off x="914405" y="2331720"/>
+            <a:ext cx="2148840" cy="3931920"/>
           </a:xfrm>
           <a:prstGeom prst="rect">
             <a:avLst/>
@@ -7556,7 +7419,26 @@
               </a:defRPr>
             </a:pPr>
             <a:r>
-              <a:t>AI &amp; LLM Services (Google Gemini 2.5 Flash)</a:t>
+              <a:t>Step 3: Human Review</a:t>
+            </a:r>
+          </a:p>
+          <a:p>
+            <a:pPr>
+              <a:spcBef>
+                <a:spcPts val="200"/>
+              </a:spcBef>
+              <a:spcAft>
+                <a:spcPts val="800"/>
+              </a:spcAft>
+              <a:defRPr sz="1100" b="1">
+                <a:solidFill>
+                  <a:srgbClr val="10B981"/>
+                </a:solidFill>
+                <a:latin typeface="Inter"/>
+              </a:defRPr>
+            </a:pPr>
+            <a:r>
+              <a:t>CA Signoff Checkpoint</a:t>
             </a:r>
           </a:p>
           <a:p>
@@ -7564,7 +7446,7 @@
               <a:spcBef>
                 <a:spcPts val="400"/>
               </a:spcBef>
-              <a:defRPr sz="1100">
+              <a:defRPr sz="1000">
                 <a:solidFill>
                   <a:srgbClr val="64748B"/>
                 </a:solidFill>
@@ -7572,21 +7454,53 @@
               </a:defRPr>
             </a:pPr>
             <a:r>
-              <a:t>Google Gemini 2.5 Flash SDK (google.genai) • Vision OCR invoice field extraction • Prompt caching &amp; SHA256 disk cache (0ms repeat responses)</a:t>
-            </a:r>
-          </a:p>
-        </p:txBody>
-      </p:sp>
-      <p:sp>
-        <p:nvSpPr>
-          <p:cNvPr id="17" name="Rounded Rectangle 16"/>
+              <a:t>• Split-screen PDF viewer + journal</a:t>
+            </a:r>
+          </a:p>
+          <a:p>
+            <a:pPr>
+              <a:spcBef>
+                <a:spcPts val="400"/>
+              </a:spcBef>
+              <a:defRPr sz="1000">
+                <a:solidFill>
+                  <a:srgbClr val="64748B"/>
+                </a:solidFill>
+                <a:latin typeface="Inter"/>
+              </a:defRPr>
+            </a:pPr>
+            <a:r>
+              <a:t>• Validates $Dr. Exp + Dr. Tax = Cr. AP$</a:t>
+            </a:r>
+          </a:p>
+          <a:p>
+            <a:pPr>
+              <a:spcBef>
+                <a:spcPts val="400"/>
+              </a:spcBef>
+              <a:defRPr sz="1000">
+                <a:solidFill>
+                  <a:srgbClr val="64748B"/>
+                </a:solidFill>
+                <a:latin typeface="Inter"/>
+              </a:defRPr>
+            </a:pPr>
+            <a:r>
+              <a:t>• 1-click approve or reject with comments</a:t>
+            </a:r>
+          </a:p>
+        </p:txBody>
+      </p:sp>
+      <p:sp>
+        <p:nvSpPr>
+          <p:cNvPr id="20" name="Rounded Rectangle 19"/>
           <p:cNvSpPr/>
           <p:nvPr/>
         </p:nvSpPr>
         <p:spPr>
           <a:xfrm>
-            <a:off x="768096" y="1453900"/>
-            <a:ext cx="10725912" cy="1115568"/>
+            <a:off x="768104" y="1499616"/>
+            <a:ext cx="2514600" cy="4937760"/>
           </a:xfrm>
           <a:prstGeom prst="roundRect">
             <a:avLst/>
@@ -7622,14 +7536,14 @@
       </p:sp>
       <p:sp>
         <p:nvSpPr>
-          <p:cNvPr id="18" name="Rounded Rectangle 17"/>
+          <p:cNvPr id="21" name="Rounded Rectangle 20"/>
           <p:cNvSpPr/>
           <p:nvPr/>
         </p:nvSpPr>
         <p:spPr>
           <a:xfrm>
-            <a:off x="731520" y="1417324"/>
-            <a:ext cx="10725912" cy="1115568"/>
+            <a:off x="731528" y="1463040"/>
+            <a:ext cx="2514600" cy="4937760"/>
           </a:xfrm>
           <a:prstGeom prst="roundRect">
             <a:avLst/>
@@ -7667,20 +7581,20 @@
       </p:sp>
       <p:sp>
         <p:nvSpPr>
-          <p:cNvPr id="19" name="Rectangle 18"/>
+          <p:cNvPr id="22" name="Oval 21"/>
           <p:cNvSpPr/>
           <p:nvPr/>
         </p:nvSpPr>
         <p:spPr>
           <a:xfrm>
-            <a:off x="731520" y="1417324"/>
-            <a:ext cx="50800" cy="1115568"/>
-          </a:xfrm>
-          <a:prstGeom prst="rect">
-            <a:avLst/>
-          </a:prstGeom>
-          <a:solidFill>
-            <a:srgbClr val="4338CA"/>
+            <a:off x="1691648" y="1645920"/>
+            <a:ext cx="594360" cy="594360"/>
+          </a:xfrm>
+          <a:prstGeom prst="ellipse">
+            <a:avLst/>
+          </a:prstGeom>
+          <a:solidFill>
+            <a:srgbClr val="10B981"/>
           </a:solidFill>
           <a:ln>
             <a:noFill/>
@@ -7710,14 +7624,49 @@
       </p:sp>
       <p:sp>
         <p:nvSpPr>
-          <p:cNvPr id="20" name="TextBox 19"/>
+          <p:cNvPr id="23" name="TextBox 22"/>
           <p:cNvSpPr txBox="1"/>
           <p:nvPr/>
         </p:nvSpPr>
         <p:spPr>
           <a:xfrm>
-            <a:off x="1005840" y="1527052"/>
-            <a:ext cx="10332720" cy="914400"/>
+            <a:off x="1691648" y="1645920"/>
+            <a:ext cx="594360" cy="594360"/>
+          </a:xfrm>
+          <a:prstGeom prst="rect">
+            <a:avLst/>
+          </a:prstGeom>
+          <a:noFill/>
+        </p:spPr>
+        <p:txBody>
+          <a:bodyPr wrap="none">
+            <a:spAutoFit/>
+          </a:bodyPr>
+          <a:lstStyle/>
+          <a:p>
+            <a:pPr algn="ctr">
+              <a:defRPr sz="1400" b="1">
+                <a:solidFill>
+                  <a:srgbClr val="FFFFFF"/>
+                </a:solidFill>
+              </a:defRPr>
+            </a:pPr>
+            <a:r>
+              <a:t>4</a:t>
+            </a:r>
+          </a:p>
+        </p:txBody>
+      </p:sp>
+      <p:sp>
+        <p:nvSpPr>
+          <p:cNvPr id="24" name="TextBox 23"/>
+          <p:cNvSpPr txBox="1"/>
+          <p:nvPr/>
+        </p:nvSpPr>
+        <p:spPr>
+          <a:xfrm>
+            <a:off x="914408" y="2331720"/>
+            <a:ext cx="2148840" cy="3931920"/>
           </a:xfrm>
           <a:prstGeom prst="rect">
             <a:avLst/>
@@ -7739,7 +7688,26 @@
               </a:defRPr>
             </a:pPr>
             <a:r>
-              <a:t>Data &amp; Storage Engine (22 Relational Models)</a:t>
+              <a:t>Step 4: Commit</a:t>
+            </a:r>
+          </a:p>
+          <a:p>
+            <a:pPr>
+              <a:spcBef>
+                <a:spcPts val="200"/>
+              </a:spcBef>
+              <a:spcAft>
+                <a:spcPts val="800"/>
+              </a:spcAft>
+              <a:defRPr sz="1100" b="1">
+                <a:solidFill>
+                  <a:srgbClr val="10B981"/>
+                </a:solidFill>
+                <a:latin typeface="Inter"/>
+              </a:defRPr>
+            </a:pPr>
+            <a:r>
+              <a:t>Immutable Ledger</a:t>
             </a:r>
           </a:p>
           <a:p>
@@ -7747,7 +7715,7 @@
               <a:spcBef>
                 <a:spcPts val="400"/>
               </a:spcBef>
-              <a:defRPr sz="1100">
+              <a:defRPr sz="1000">
                 <a:solidFill>
                   <a:srgbClr val="64748B"/>
                 </a:solidFill>
@@ -7755,7 +7723,39 @@
               </a:defRPr>
             </a:pPr>
             <a:r>
-              <a:t>PostgreSQL 16 / SQLite 3 Relational Engine (22 SQLAlchemy ORM models) • Redis task queue &amp; S3 document storage • Immutable audit log table</a:t>
+              <a:t>• Double-entry posted to database</a:t>
+            </a:r>
+          </a:p>
+          <a:p>
+            <a:pPr>
+              <a:spcBef>
+                <a:spcPts val="400"/>
+              </a:spcBef>
+              <a:defRPr sz="1000">
+                <a:solidFill>
+                  <a:srgbClr val="64748B"/>
+                </a:solidFill>
+                <a:latin typeface="Inter"/>
+              </a:defRPr>
+            </a:pPr>
+            <a:r>
+              <a:t>• Journal marked immutable</a:t>
+            </a:r>
+          </a:p>
+          <a:p>
+            <a:pPr>
+              <a:spcBef>
+                <a:spcPts val="400"/>
+              </a:spcBef>
+              <a:defRPr sz="1000">
+                <a:solidFill>
+                  <a:srgbClr val="64748B"/>
+                </a:solidFill>
+                <a:latin typeface="Inter"/>
+              </a:defRPr>
+            </a:pPr>
+            <a:r>
+              <a:t>• P&amp;L and Balance Sheet update live</a:t>
             </a:r>
           </a:p>
         </p:txBody>
@@ -7895,7 +7895,7 @@
               </a:defRPr>
             </a:pPr>
             <a:r>
-              <a:t>The 10 Specialized AI Agents Roster</a:t>
+              <a:t>Production Infrastructure &amp; Hybrid Storage</a:t>
             </a:r>
           </a:p>
           <a:p>
@@ -7908,7 +7908,7 @@
               </a:defRPr>
             </a:pPr>
             <a:r>
-              <a:t>Decoupled execution graph with focused context scoping and zero token bloat</a:t>
+              <a:t>Full-Stack Cloud Architecture (Vercel + Render + Supabase)</a:t>
             </a:r>
           </a:p>
         </p:txBody>
@@ -7921,8 +7921,8 @@
         </p:nvSpPr>
         <p:spPr>
           <a:xfrm>
-            <a:off x="768096" y="1499616"/>
-            <a:ext cx="2057400" cy="2240280"/>
+            <a:off x="768096" y="1453896"/>
+            <a:ext cx="10725912" cy="1115568"/>
           </a:xfrm>
           <a:prstGeom prst="roundRect">
             <a:avLst/>
@@ -7964,8 +7964,8 @@
         </p:nvSpPr>
         <p:spPr>
           <a:xfrm>
-            <a:off x="731520" y="1463040"/>
-            <a:ext cx="2057400" cy="2240280"/>
+            <a:off x="731520" y="1417320"/>
+            <a:ext cx="10725912" cy="1115568"/>
           </a:xfrm>
           <a:prstGeom prst="roundRect">
             <a:avLst/>
@@ -8009,8 +8009,8 @@
         </p:nvSpPr>
         <p:spPr>
           <a:xfrm>
-            <a:off x="731520" y="1463040"/>
-            <a:ext cx="2057400" cy="50800"/>
+            <a:off x="731520" y="1417320"/>
+            <a:ext cx="50800" cy="1115568"/>
           </a:xfrm>
           <a:prstGeom prst="rect">
             <a:avLst/>
@@ -8052,8 +8052,8 @@
         </p:nvSpPr>
         <p:spPr>
           <a:xfrm>
-            <a:off x="841248" y="1600200"/>
-            <a:ext cx="1828800" cy="1965960"/>
+            <a:off x="1005840" y="1527048"/>
+            <a:ext cx="10332720" cy="914400"/>
           </a:xfrm>
           <a:prstGeom prst="rect">
             <a:avLst/>
@@ -8067,7 +8067,7 @@
           <a:lstStyle/>
           <a:p>
             <a:pPr>
-              <a:defRPr sz="1300" b="1">
+              <a:defRPr sz="1400" b="1">
                 <a:solidFill>
                   <a:srgbClr val="0F172A"/>
                 </a:solidFill>
@@ -8075,15 +8075,15 @@
               </a:defRPr>
             </a:pPr>
             <a:r>
-              <a:t>Supervisor Agent</a:t>
+              <a:t>Vercel Frontend CDN (React 18 + Vite)</a:t>
             </a:r>
           </a:p>
           <a:p>
             <a:pPr>
               <a:spcBef>
-                <a:spcPts val="600"/>
+                <a:spcPts val="400"/>
               </a:spcBef>
-              <a:defRPr sz="1000">
+              <a:defRPr sz="1100">
                 <a:solidFill>
                   <a:srgbClr val="64748B"/>
                 </a:solidFill>
@@ -8091,7 +8091,7 @@
               </a:defRPr>
             </a:pPr>
             <a:r>
-              <a:t>Orchestrates execution graph &amp; human approval checkpoints</a:t>
+              <a:t>Global CDN static hosting with Mobile Navigation Drawer, responsive table-to-card transformations, and Command Palette (Cmd+K).</a:t>
             </a:r>
           </a:p>
         </p:txBody>
@@ -8104,8 +8104,8 @@
         </p:nvSpPr>
         <p:spPr>
           <a:xfrm>
-            <a:off x="768098" y="1499616"/>
-            <a:ext cx="2057400" cy="2240280"/>
+            <a:off x="768096" y="1453897"/>
+            <a:ext cx="10725912" cy="1115568"/>
           </a:xfrm>
           <a:prstGeom prst="roundRect">
             <a:avLst/>
@@ -8147,8 +8147,8 @@
         </p:nvSpPr>
         <p:spPr>
           <a:xfrm>
-            <a:off x="731522" y="1463040"/>
-            <a:ext cx="2057400" cy="2240280"/>
+            <a:off x="731520" y="1417321"/>
+            <a:ext cx="10725912" cy="1115568"/>
           </a:xfrm>
           <a:prstGeom prst="roundRect">
             <a:avLst/>
@@ -8192,8 +8192,8 @@
         </p:nvSpPr>
         <p:spPr>
           <a:xfrm>
-            <a:off x="731522" y="1463040"/>
-            <a:ext cx="2057400" cy="50800"/>
+            <a:off x="731520" y="1417321"/>
+            <a:ext cx="50800" cy="1115568"/>
           </a:xfrm>
           <a:prstGeom prst="rect">
             <a:avLst/>
@@ -8235,8 +8235,8 @@
         </p:nvSpPr>
         <p:spPr>
           <a:xfrm>
-            <a:off x="841250" y="1600200"/>
-            <a:ext cx="1828800" cy="1965960"/>
+            <a:off x="1005840" y="1527049"/>
+            <a:ext cx="10332720" cy="914400"/>
           </a:xfrm>
           <a:prstGeom prst="rect">
             <a:avLst/>
@@ -8250,7 +8250,7 @@
           <a:lstStyle/>
           <a:p>
             <a:pPr>
-              <a:defRPr sz="1300" b="1">
+              <a:defRPr sz="1400" b="1">
                 <a:solidFill>
                   <a:srgbClr val="0F172A"/>
                 </a:solidFill>
@@ -8258,15 +8258,15 @@
               </a:defRPr>
             </a:pPr>
             <a:r>
-              <a:t>Invoice Agent</a:t>
+              <a:t>Render FastAPI Backend (Python 3.11)</a:t>
             </a:r>
           </a:p>
           <a:p>
             <a:pPr>
               <a:spcBef>
-                <a:spcPts val="600"/>
+                <a:spcPts val="400"/>
               </a:spcBef>
-              <a:defRPr sz="1000">
+              <a:defRPr sz="1100">
                 <a:solidFill>
                   <a:srgbClr val="64748B"/>
                 </a:solidFill>
@@ -8274,7 +8274,7 @@
               </a:defRPr>
             </a:pPr>
             <a:r>
-              <a:t>Vision OCR extraction &amp; HSN/SAC code classification</a:t>
+              <a:t>Asynchronous Python 3.11 ASGI service executing Codex AI Vision OCR, fuzzy bank matching, and Pydantic validation.</a:t>
             </a:r>
           </a:p>
         </p:txBody>
@@ -8287,8 +8287,8 @@
         </p:nvSpPr>
         <p:spPr>
           <a:xfrm>
-            <a:off x="768100" y="1499616"/>
-            <a:ext cx="2057400" cy="2240280"/>
+            <a:off x="768096" y="1453898"/>
+            <a:ext cx="10725912" cy="1115568"/>
           </a:xfrm>
           <a:prstGeom prst="roundRect">
             <a:avLst/>
@@ -8330,8 +8330,8 @@
         </p:nvSpPr>
         <p:spPr>
           <a:xfrm>
-            <a:off x="731524" y="1463040"/>
-            <a:ext cx="2057400" cy="2240280"/>
+            <a:off x="731520" y="1417322"/>
+            <a:ext cx="10725912" cy="1115568"/>
           </a:xfrm>
           <a:prstGeom prst="roundRect">
             <a:avLst/>
@@ -8375,8 +8375,8 @@
         </p:nvSpPr>
         <p:spPr>
           <a:xfrm>
-            <a:off x="731524" y="1463040"/>
-            <a:ext cx="2057400" cy="50800"/>
+            <a:off x="731520" y="1417322"/>
+            <a:ext cx="50800" cy="1115568"/>
           </a:xfrm>
           <a:prstGeom prst="rect">
             <a:avLst/>
@@ -8418,8 +8418,8 @@
         </p:nvSpPr>
         <p:spPr>
           <a:xfrm>
-            <a:off x="841252" y="1600200"/>
-            <a:ext cx="1828800" cy="1965960"/>
+            <a:off x="1005840" y="1527050"/>
+            <a:ext cx="10332720" cy="914400"/>
           </a:xfrm>
           <a:prstGeom prst="rect">
             <a:avLst/>
@@ -8433,7 +8433,7 @@
           <a:lstStyle/>
           <a:p>
             <a:pPr>
-              <a:defRPr sz="1300" b="1">
+              <a:defRPr sz="1400" b="1">
                 <a:solidFill>
                   <a:srgbClr val="0F172A"/>
                 </a:solidFill>
@@ -8441,15 +8441,15 @@
               </a:defRPr>
             </a:pPr>
             <a:r>
-              <a:t>Ledger Agent</a:t>
+              <a:t>Supabase Cloud Database (PostgreSQL)</a:t>
             </a:r>
           </a:p>
           <a:p>
             <a:pPr>
               <a:spcBef>
-                <a:spcPts val="600"/>
+                <a:spcPts val="400"/>
               </a:spcBef>
-              <a:defRPr sz="1000">
+              <a:defRPr sz="1100">
                 <a:solidFill>
                   <a:srgbClr val="64748B"/>
                 </a:solidFill>
@@ -8457,7 +8457,7 @@
               </a:defRPr>
             </a:pPr>
             <a:r>
-              <a:t>Immutable double-entry debit equal credit equality</a:t>
+              <a:t>Central cloud database storing registered User Profiles (`profiles`) and Firm Entity Masters (`organizations`) with Row-Level Security.</a:t>
             </a:r>
           </a:p>
         </p:txBody>
@@ -8470,8 +8470,8 @@
         </p:nvSpPr>
         <p:spPr>
           <a:xfrm>
-            <a:off x="768103" y="1499616"/>
-            <a:ext cx="2057400" cy="2240280"/>
+            <a:off x="768096" y="1453900"/>
+            <a:ext cx="10725912" cy="1115568"/>
           </a:xfrm>
           <a:prstGeom prst="roundRect">
             <a:avLst/>
@@ -8513,8 +8513,8 @@
         </p:nvSpPr>
         <p:spPr>
           <a:xfrm>
-            <a:off x="731527" y="1463040"/>
-            <a:ext cx="2057400" cy="2240280"/>
+            <a:off x="731520" y="1417324"/>
+            <a:ext cx="10725912" cy="1115568"/>
           </a:xfrm>
           <a:prstGeom prst="roundRect">
             <a:avLst/>
@@ -8558,8 +8558,8 @@
         </p:nvSpPr>
         <p:spPr>
           <a:xfrm>
-            <a:off x="731527" y="1463040"/>
-            <a:ext cx="2057400" cy="50800"/>
+            <a:off x="731520" y="1417324"/>
+            <a:ext cx="50800" cy="1115568"/>
           </a:xfrm>
           <a:prstGeom prst="rect">
             <a:avLst/>
@@ -8601,8 +8601,8 @@
         </p:nvSpPr>
         <p:spPr>
           <a:xfrm>
-            <a:off x="841255" y="1600200"/>
-            <a:ext cx="1828800" cy="1965960"/>
+            <a:off x="1005840" y="1527052"/>
+            <a:ext cx="10332720" cy="914400"/>
           </a:xfrm>
           <a:prstGeom prst="rect">
             <a:avLst/>
@@ -8616,7 +8616,7 @@
           <a:lstStyle/>
           <a:p>
             <a:pPr>
-              <a:defRPr sz="1300" b="1">
+              <a:defRPr sz="1400" b="1">
                 <a:solidFill>
                   <a:srgbClr val="0F172A"/>
                 </a:solidFill>
@@ -8624,15 +8624,15 @@
               </a:defRPr>
             </a:pPr>
             <a:r>
-              <a:t>GST Agent</a:t>
+              <a:t>Client Device Local Storage (localStorage)</a:t>
             </a:r>
           </a:p>
           <a:p>
             <a:pPr>
               <a:spcBef>
-                <a:spcPts val="600"/>
+                <a:spcPts val="400"/>
               </a:spcBef>
-              <a:defRPr sz="1000">
+              <a:defRPr sz="1100">
                 <a:solidFill>
                   <a:srgbClr val="64748B"/>
                 </a:solidFill>
@@ -8640,1105 +8640,7 @@
               </a:defRPr>
             </a:pPr>
             <a:r>
-              <a:t>Validates 15-char GSTINs &amp; GSTR-2B ITC eligibility</a:t>
-            </a:r>
-          </a:p>
-        </p:txBody>
-      </p:sp>
-      <p:sp>
-        <p:nvSpPr>
-          <p:cNvPr id="21" name="Rounded Rectangle 20"/>
-          <p:cNvSpPr/>
-          <p:nvPr/>
-        </p:nvSpPr>
-        <p:spPr>
-          <a:xfrm>
-            <a:off x="768105" y="1499616"/>
-            <a:ext cx="2057400" cy="2240280"/>
-          </a:xfrm>
-          <a:prstGeom prst="roundRect">
-            <a:avLst/>
-          </a:prstGeom>
-          <a:solidFill>
-            <a:srgbClr val="EBF0F5"/>
-          </a:solidFill>
-          <a:ln>
-            <a:noFill/>
-          </a:ln>
-        </p:spPr>
-        <p:style>
-          <a:lnRef idx="1">
-            <a:schemeClr val="accent1"/>
-          </a:lnRef>
-          <a:fillRef idx="3">
-            <a:schemeClr val="accent1"/>
-          </a:fillRef>
-          <a:effectRef idx="2">
-            <a:schemeClr val="accent1"/>
-          </a:effectRef>
-          <a:fontRef idx="minor">
-            <a:schemeClr val="lt1"/>
-          </a:fontRef>
-        </p:style>
-        <p:txBody>
-          <a:bodyPr rtlCol="0" anchor="ctr"/>
-          <a:lstStyle/>
-          <a:p>
-            <a:pPr algn="ctr"/>
-          </a:p>
-        </p:txBody>
-      </p:sp>
-      <p:sp>
-        <p:nvSpPr>
-          <p:cNvPr id="22" name="Rounded Rectangle 21"/>
-          <p:cNvSpPr/>
-          <p:nvPr/>
-        </p:nvSpPr>
-        <p:spPr>
-          <a:xfrm>
-            <a:off x="731529" y="1463040"/>
-            <a:ext cx="2057400" cy="2240280"/>
-          </a:xfrm>
-          <a:prstGeom prst="roundRect">
-            <a:avLst/>
-          </a:prstGeom>
-          <a:solidFill>
-            <a:srgbClr val="FFFFFF"/>
-          </a:solidFill>
-          <a:ln>
-            <a:solidFill>
-              <a:srgbClr val="E2E8F0"/>
-            </a:solidFill>
-          </a:ln>
-        </p:spPr>
-        <p:style>
-          <a:lnRef idx="1">
-            <a:schemeClr val="accent1"/>
-          </a:lnRef>
-          <a:fillRef idx="3">
-            <a:schemeClr val="accent1"/>
-          </a:fillRef>
-          <a:effectRef idx="2">
-            <a:schemeClr val="accent1"/>
-          </a:effectRef>
-          <a:fontRef idx="minor">
-            <a:schemeClr val="lt1"/>
-          </a:fontRef>
-        </p:style>
-        <p:txBody>
-          <a:bodyPr rtlCol="0" anchor="ctr"/>
-          <a:lstStyle/>
-          <a:p>
-            <a:pPr algn="ctr"/>
-          </a:p>
-        </p:txBody>
-      </p:sp>
-      <p:sp>
-        <p:nvSpPr>
-          <p:cNvPr id="23" name="Rectangle 22"/>
-          <p:cNvSpPr/>
-          <p:nvPr/>
-        </p:nvSpPr>
-        <p:spPr>
-          <a:xfrm>
-            <a:off x="731529" y="1463040"/>
-            <a:ext cx="2057400" cy="50800"/>
-          </a:xfrm>
-          <a:prstGeom prst="rect">
-            <a:avLst/>
-          </a:prstGeom>
-          <a:solidFill>
-            <a:srgbClr val="4338CA"/>
-          </a:solidFill>
-          <a:ln>
-            <a:noFill/>
-          </a:ln>
-        </p:spPr>
-        <p:style>
-          <a:lnRef idx="1">
-            <a:schemeClr val="accent1"/>
-          </a:lnRef>
-          <a:fillRef idx="3">
-            <a:schemeClr val="accent1"/>
-          </a:fillRef>
-          <a:effectRef idx="2">
-            <a:schemeClr val="accent1"/>
-          </a:effectRef>
-          <a:fontRef idx="minor">
-            <a:schemeClr val="lt1"/>
-          </a:fontRef>
-        </p:style>
-        <p:txBody>
-          <a:bodyPr rtlCol="0" anchor="ctr"/>
-          <a:lstStyle/>
-          <a:p>
-            <a:pPr algn="ctr"/>
-          </a:p>
-        </p:txBody>
-      </p:sp>
-      <p:sp>
-        <p:nvSpPr>
-          <p:cNvPr id="24" name="TextBox 23"/>
-          <p:cNvSpPr txBox="1"/>
-          <p:nvPr/>
-        </p:nvSpPr>
-        <p:spPr>
-          <a:xfrm>
-            <a:off x="841257" y="1600200"/>
-            <a:ext cx="1828800" cy="1965960"/>
-          </a:xfrm>
-          <a:prstGeom prst="rect">
-            <a:avLst/>
-          </a:prstGeom>
-          <a:noFill/>
-        </p:spPr>
-        <p:txBody>
-          <a:bodyPr wrap="square">
-            <a:spAutoFit/>
-          </a:bodyPr>
-          <a:lstStyle/>
-          <a:p>
-            <a:pPr>
-              <a:defRPr sz="1300" b="1">
-                <a:solidFill>
-                  <a:srgbClr val="0F172A"/>
-                </a:solidFill>
-                <a:latin typeface="Inter"/>
-              </a:defRPr>
-            </a:pPr>
-            <a:r>
-              <a:t>TDS Agent</a:t>
-            </a:r>
-          </a:p>
-          <a:p>
-            <a:pPr>
-              <a:spcBef>
-                <a:spcPts val="600"/>
-              </a:spcBef>
-              <a:defRPr sz="1000">
-                <a:solidFill>
-                  <a:srgbClr val="64748B"/>
-                </a:solidFill>
-                <a:latin typeface="Inter"/>
-              </a:defRPr>
-            </a:pPr>
-            <a:r>
-              <a:t>Section 194C/194J cumulative vendor limit calculator</a:t>
-            </a:r>
-          </a:p>
-        </p:txBody>
-      </p:sp>
-      <p:sp>
-        <p:nvSpPr>
-          <p:cNvPr id="25" name="Rounded Rectangle 24"/>
-          <p:cNvSpPr/>
-          <p:nvPr/>
-        </p:nvSpPr>
-        <p:spPr>
-          <a:xfrm>
-            <a:off x="768096" y="1499618"/>
-            <a:ext cx="2057400" cy="2240280"/>
-          </a:xfrm>
-          <a:prstGeom prst="roundRect">
-            <a:avLst/>
-          </a:prstGeom>
-          <a:solidFill>
-            <a:srgbClr val="EBF0F5"/>
-          </a:solidFill>
-          <a:ln>
-            <a:noFill/>
-          </a:ln>
-        </p:spPr>
-        <p:style>
-          <a:lnRef idx="1">
-            <a:schemeClr val="accent1"/>
-          </a:lnRef>
-          <a:fillRef idx="3">
-            <a:schemeClr val="accent1"/>
-          </a:fillRef>
-          <a:effectRef idx="2">
-            <a:schemeClr val="accent1"/>
-          </a:effectRef>
-          <a:fontRef idx="minor">
-            <a:schemeClr val="lt1"/>
-          </a:fontRef>
-        </p:style>
-        <p:txBody>
-          <a:bodyPr rtlCol="0" anchor="ctr"/>
-          <a:lstStyle/>
-          <a:p>
-            <a:pPr algn="ctr"/>
-          </a:p>
-        </p:txBody>
-      </p:sp>
-      <p:sp>
-        <p:nvSpPr>
-          <p:cNvPr id="26" name="Rounded Rectangle 25"/>
-          <p:cNvSpPr/>
-          <p:nvPr/>
-        </p:nvSpPr>
-        <p:spPr>
-          <a:xfrm>
-            <a:off x="731520" y="1463042"/>
-            <a:ext cx="2057400" cy="2240280"/>
-          </a:xfrm>
-          <a:prstGeom prst="roundRect">
-            <a:avLst/>
-          </a:prstGeom>
-          <a:solidFill>
-            <a:srgbClr val="FFFFFF"/>
-          </a:solidFill>
-          <a:ln>
-            <a:solidFill>
-              <a:srgbClr val="E2E8F0"/>
-            </a:solidFill>
-          </a:ln>
-        </p:spPr>
-        <p:style>
-          <a:lnRef idx="1">
-            <a:schemeClr val="accent1"/>
-          </a:lnRef>
-          <a:fillRef idx="3">
-            <a:schemeClr val="accent1"/>
-          </a:fillRef>
-          <a:effectRef idx="2">
-            <a:schemeClr val="accent1"/>
-          </a:effectRef>
-          <a:fontRef idx="minor">
-            <a:schemeClr val="lt1"/>
-          </a:fontRef>
-        </p:style>
-        <p:txBody>
-          <a:bodyPr rtlCol="0" anchor="ctr"/>
-          <a:lstStyle/>
-          <a:p>
-            <a:pPr algn="ctr"/>
-          </a:p>
-        </p:txBody>
-      </p:sp>
-      <p:sp>
-        <p:nvSpPr>
-          <p:cNvPr id="27" name="Rectangle 26"/>
-          <p:cNvSpPr/>
-          <p:nvPr/>
-        </p:nvSpPr>
-        <p:spPr>
-          <a:xfrm>
-            <a:off x="731520" y="1463042"/>
-            <a:ext cx="2057400" cy="50800"/>
-          </a:xfrm>
-          <a:prstGeom prst="rect">
-            <a:avLst/>
-          </a:prstGeom>
-          <a:solidFill>
-            <a:srgbClr val="4338CA"/>
-          </a:solidFill>
-          <a:ln>
-            <a:noFill/>
-          </a:ln>
-        </p:spPr>
-        <p:style>
-          <a:lnRef idx="1">
-            <a:schemeClr val="accent1"/>
-          </a:lnRef>
-          <a:fillRef idx="3">
-            <a:schemeClr val="accent1"/>
-          </a:fillRef>
-          <a:effectRef idx="2">
-            <a:schemeClr val="accent1"/>
-          </a:effectRef>
-          <a:fontRef idx="minor">
-            <a:schemeClr val="lt1"/>
-          </a:fontRef>
-        </p:style>
-        <p:txBody>
-          <a:bodyPr rtlCol="0" anchor="ctr"/>
-          <a:lstStyle/>
-          <a:p>
-            <a:pPr algn="ctr"/>
-          </a:p>
-        </p:txBody>
-      </p:sp>
-      <p:sp>
-        <p:nvSpPr>
-          <p:cNvPr id="28" name="TextBox 27"/>
-          <p:cNvSpPr txBox="1"/>
-          <p:nvPr/>
-        </p:nvSpPr>
-        <p:spPr>
-          <a:xfrm>
-            <a:off x="841248" y="1600202"/>
-            <a:ext cx="1828800" cy="1965960"/>
-          </a:xfrm>
-          <a:prstGeom prst="rect">
-            <a:avLst/>
-          </a:prstGeom>
-          <a:noFill/>
-        </p:spPr>
-        <p:txBody>
-          <a:bodyPr wrap="square">
-            <a:spAutoFit/>
-          </a:bodyPr>
-          <a:lstStyle/>
-          <a:p>
-            <a:pPr>
-              <a:defRPr sz="1300" b="1">
-                <a:solidFill>
-                  <a:srgbClr val="0F172A"/>
-                </a:solidFill>
-                <a:latin typeface="Inter"/>
-              </a:defRPr>
-            </a:pPr>
-            <a:r>
-              <a:t>Bank Rec Agent</a:t>
-            </a:r>
-          </a:p>
-          <a:p>
-            <a:pPr>
-              <a:spcBef>
-                <a:spcPts val="600"/>
-              </a:spcBef>
-              <a:defRPr sz="1000">
-                <a:solidFill>
-                  <a:srgbClr val="64748B"/>
-                </a:solidFill>
-                <a:latin typeface="Inter"/>
-              </a:defRPr>
-            </a:pPr>
-            <a:r>
-              <a:t>Fuzzy string &amp; amount similarity matching engine</a:t>
-            </a:r>
-          </a:p>
-        </p:txBody>
-      </p:sp>
-      <p:sp>
-        <p:nvSpPr>
-          <p:cNvPr id="29" name="Rounded Rectangle 28"/>
-          <p:cNvSpPr/>
-          <p:nvPr/>
-        </p:nvSpPr>
-        <p:spPr>
-          <a:xfrm>
-            <a:off x="768098" y="1499618"/>
-            <a:ext cx="2057400" cy="2240280"/>
-          </a:xfrm>
-          <a:prstGeom prst="roundRect">
-            <a:avLst/>
-          </a:prstGeom>
-          <a:solidFill>
-            <a:srgbClr val="EBF0F5"/>
-          </a:solidFill>
-          <a:ln>
-            <a:noFill/>
-          </a:ln>
-        </p:spPr>
-        <p:style>
-          <a:lnRef idx="1">
-            <a:schemeClr val="accent1"/>
-          </a:lnRef>
-          <a:fillRef idx="3">
-            <a:schemeClr val="accent1"/>
-          </a:fillRef>
-          <a:effectRef idx="2">
-            <a:schemeClr val="accent1"/>
-          </a:effectRef>
-          <a:fontRef idx="minor">
-            <a:schemeClr val="lt1"/>
-          </a:fontRef>
-        </p:style>
-        <p:txBody>
-          <a:bodyPr rtlCol="0" anchor="ctr"/>
-          <a:lstStyle/>
-          <a:p>
-            <a:pPr algn="ctr"/>
-          </a:p>
-        </p:txBody>
-      </p:sp>
-      <p:sp>
-        <p:nvSpPr>
-          <p:cNvPr id="30" name="Rounded Rectangle 29"/>
-          <p:cNvSpPr/>
-          <p:nvPr/>
-        </p:nvSpPr>
-        <p:spPr>
-          <a:xfrm>
-            <a:off x="731522" y="1463042"/>
-            <a:ext cx="2057400" cy="2240280"/>
-          </a:xfrm>
-          <a:prstGeom prst="roundRect">
-            <a:avLst/>
-          </a:prstGeom>
-          <a:solidFill>
-            <a:srgbClr val="FFFFFF"/>
-          </a:solidFill>
-          <a:ln>
-            <a:solidFill>
-              <a:srgbClr val="E2E8F0"/>
-            </a:solidFill>
-          </a:ln>
-        </p:spPr>
-        <p:style>
-          <a:lnRef idx="1">
-            <a:schemeClr val="accent1"/>
-          </a:lnRef>
-          <a:fillRef idx="3">
-            <a:schemeClr val="accent1"/>
-          </a:fillRef>
-          <a:effectRef idx="2">
-            <a:schemeClr val="accent1"/>
-          </a:effectRef>
-          <a:fontRef idx="minor">
-            <a:schemeClr val="lt1"/>
-          </a:fontRef>
-        </p:style>
-        <p:txBody>
-          <a:bodyPr rtlCol="0" anchor="ctr"/>
-          <a:lstStyle/>
-          <a:p>
-            <a:pPr algn="ctr"/>
-          </a:p>
-        </p:txBody>
-      </p:sp>
-      <p:sp>
-        <p:nvSpPr>
-          <p:cNvPr id="31" name="Rectangle 30"/>
-          <p:cNvSpPr/>
-          <p:nvPr/>
-        </p:nvSpPr>
-        <p:spPr>
-          <a:xfrm>
-            <a:off x="731522" y="1463042"/>
-            <a:ext cx="2057400" cy="50800"/>
-          </a:xfrm>
-          <a:prstGeom prst="rect">
-            <a:avLst/>
-          </a:prstGeom>
-          <a:solidFill>
-            <a:srgbClr val="4338CA"/>
-          </a:solidFill>
-          <a:ln>
-            <a:noFill/>
-          </a:ln>
-        </p:spPr>
-        <p:style>
-          <a:lnRef idx="1">
-            <a:schemeClr val="accent1"/>
-          </a:lnRef>
-          <a:fillRef idx="3">
-            <a:schemeClr val="accent1"/>
-          </a:fillRef>
-          <a:effectRef idx="2">
-            <a:schemeClr val="accent1"/>
-          </a:effectRef>
-          <a:fontRef idx="minor">
-            <a:schemeClr val="lt1"/>
-          </a:fontRef>
-        </p:style>
-        <p:txBody>
-          <a:bodyPr rtlCol="0" anchor="ctr"/>
-          <a:lstStyle/>
-          <a:p>
-            <a:pPr algn="ctr"/>
-          </a:p>
-        </p:txBody>
-      </p:sp>
-      <p:sp>
-        <p:nvSpPr>
-          <p:cNvPr id="32" name="TextBox 31"/>
-          <p:cNvSpPr txBox="1"/>
-          <p:nvPr/>
-        </p:nvSpPr>
-        <p:spPr>
-          <a:xfrm>
-            <a:off x="841250" y="1600202"/>
-            <a:ext cx="1828800" cy="1965960"/>
-          </a:xfrm>
-          <a:prstGeom prst="rect">
-            <a:avLst/>
-          </a:prstGeom>
-          <a:noFill/>
-        </p:spPr>
-        <p:txBody>
-          <a:bodyPr wrap="square">
-            <a:spAutoFit/>
-          </a:bodyPr>
-          <a:lstStyle/>
-          <a:p>
-            <a:pPr>
-              <a:defRPr sz="1300" b="1">
-                <a:solidFill>
-                  <a:srgbClr val="0F172A"/>
-                </a:solidFill>
-                <a:latin typeface="Inter"/>
-              </a:defRPr>
-            </a:pPr>
-            <a:r>
-              <a:t>Compliance Agent</a:t>
-            </a:r>
-          </a:p>
-          <a:p>
-            <a:pPr>
-              <a:spcBef>
-                <a:spcPts val="600"/>
-              </a:spcBef>
-              <a:defRPr sz="1000">
-                <a:solidFill>
-                  <a:srgbClr val="64748B"/>
-                </a:solidFill>
-                <a:latin typeface="Inter"/>
-              </a:defRPr>
-            </a:pPr>
-            <a:r>
-              <a:t>Statutory filing calendar &amp; penalty risk score auditor</a:t>
-            </a:r>
-          </a:p>
-        </p:txBody>
-      </p:sp>
-      <p:sp>
-        <p:nvSpPr>
-          <p:cNvPr id="33" name="Rounded Rectangle 32"/>
-          <p:cNvSpPr/>
-          <p:nvPr/>
-        </p:nvSpPr>
-        <p:spPr>
-          <a:xfrm>
-            <a:off x="768100" y="1499618"/>
-            <a:ext cx="2057400" cy="2240280"/>
-          </a:xfrm>
-          <a:prstGeom prst="roundRect">
-            <a:avLst/>
-          </a:prstGeom>
-          <a:solidFill>
-            <a:srgbClr val="EBF0F5"/>
-          </a:solidFill>
-          <a:ln>
-            <a:noFill/>
-          </a:ln>
-        </p:spPr>
-        <p:style>
-          <a:lnRef idx="1">
-            <a:schemeClr val="accent1"/>
-          </a:lnRef>
-          <a:fillRef idx="3">
-            <a:schemeClr val="accent1"/>
-          </a:fillRef>
-          <a:effectRef idx="2">
-            <a:schemeClr val="accent1"/>
-          </a:effectRef>
-          <a:fontRef idx="minor">
-            <a:schemeClr val="lt1"/>
-          </a:fontRef>
-        </p:style>
-        <p:txBody>
-          <a:bodyPr rtlCol="0" anchor="ctr"/>
-          <a:lstStyle/>
-          <a:p>
-            <a:pPr algn="ctr"/>
-          </a:p>
-        </p:txBody>
-      </p:sp>
-      <p:sp>
-        <p:nvSpPr>
-          <p:cNvPr id="34" name="Rounded Rectangle 33"/>
-          <p:cNvSpPr/>
-          <p:nvPr/>
-        </p:nvSpPr>
-        <p:spPr>
-          <a:xfrm>
-            <a:off x="731524" y="1463042"/>
-            <a:ext cx="2057400" cy="2240280"/>
-          </a:xfrm>
-          <a:prstGeom prst="roundRect">
-            <a:avLst/>
-          </a:prstGeom>
-          <a:solidFill>
-            <a:srgbClr val="FFFFFF"/>
-          </a:solidFill>
-          <a:ln>
-            <a:solidFill>
-              <a:srgbClr val="E2E8F0"/>
-            </a:solidFill>
-          </a:ln>
-        </p:spPr>
-        <p:style>
-          <a:lnRef idx="1">
-            <a:schemeClr val="accent1"/>
-          </a:lnRef>
-          <a:fillRef idx="3">
-            <a:schemeClr val="accent1"/>
-          </a:fillRef>
-          <a:effectRef idx="2">
-            <a:schemeClr val="accent1"/>
-          </a:effectRef>
-          <a:fontRef idx="minor">
-            <a:schemeClr val="lt1"/>
-          </a:fontRef>
-        </p:style>
-        <p:txBody>
-          <a:bodyPr rtlCol="0" anchor="ctr"/>
-          <a:lstStyle/>
-          <a:p>
-            <a:pPr algn="ctr"/>
-          </a:p>
-        </p:txBody>
-      </p:sp>
-      <p:sp>
-        <p:nvSpPr>
-          <p:cNvPr id="35" name="Rectangle 34"/>
-          <p:cNvSpPr/>
-          <p:nvPr/>
-        </p:nvSpPr>
-        <p:spPr>
-          <a:xfrm>
-            <a:off x="731524" y="1463042"/>
-            <a:ext cx="2057400" cy="50800"/>
-          </a:xfrm>
-          <a:prstGeom prst="rect">
-            <a:avLst/>
-          </a:prstGeom>
-          <a:solidFill>
-            <a:srgbClr val="4338CA"/>
-          </a:solidFill>
-          <a:ln>
-            <a:noFill/>
-          </a:ln>
-        </p:spPr>
-        <p:style>
-          <a:lnRef idx="1">
-            <a:schemeClr val="accent1"/>
-          </a:lnRef>
-          <a:fillRef idx="3">
-            <a:schemeClr val="accent1"/>
-          </a:fillRef>
-          <a:effectRef idx="2">
-            <a:schemeClr val="accent1"/>
-          </a:effectRef>
-          <a:fontRef idx="minor">
-            <a:schemeClr val="lt1"/>
-          </a:fontRef>
-        </p:style>
-        <p:txBody>
-          <a:bodyPr rtlCol="0" anchor="ctr"/>
-          <a:lstStyle/>
-          <a:p>
-            <a:pPr algn="ctr"/>
-          </a:p>
-        </p:txBody>
-      </p:sp>
-      <p:sp>
-        <p:nvSpPr>
-          <p:cNvPr id="36" name="TextBox 35"/>
-          <p:cNvSpPr txBox="1"/>
-          <p:nvPr/>
-        </p:nvSpPr>
-        <p:spPr>
-          <a:xfrm>
-            <a:off x="841252" y="1600202"/>
-            <a:ext cx="1828800" cy="1965960"/>
-          </a:xfrm>
-          <a:prstGeom prst="rect">
-            <a:avLst/>
-          </a:prstGeom>
-          <a:noFill/>
-        </p:spPr>
-        <p:txBody>
-          <a:bodyPr wrap="square">
-            <a:spAutoFit/>
-          </a:bodyPr>
-          <a:lstStyle/>
-          <a:p>
-            <a:pPr>
-              <a:defRPr sz="1300" b="1">
-                <a:solidFill>
-                  <a:srgbClr val="0F172A"/>
-                </a:solidFill>
-                <a:latin typeface="Inter"/>
-              </a:defRPr>
-            </a:pPr>
-            <a:r>
-              <a:t>Reporting Agent</a:t>
-            </a:r>
-          </a:p>
-          <a:p>
-            <a:pPr>
-              <a:spcBef>
-                <a:spcPts val="600"/>
-              </a:spcBef>
-              <a:defRPr sz="1000">
-                <a:solidFill>
-                  <a:srgbClr val="64748B"/>
-                </a:solidFill>
-                <a:latin typeface="Inter"/>
-              </a:defRPr>
-            </a:pPr>
-            <a:r>
-              <a:t>Synthesizes certified P&amp;L and Balance Sheet</a:t>
-            </a:r>
-          </a:p>
-        </p:txBody>
-      </p:sp>
-      <p:sp>
-        <p:nvSpPr>
-          <p:cNvPr id="37" name="Rounded Rectangle 36"/>
-          <p:cNvSpPr/>
-          <p:nvPr/>
-        </p:nvSpPr>
-        <p:spPr>
-          <a:xfrm>
-            <a:off x="768103" y="1499618"/>
-            <a:ext cx="2057400" cy="2240280"/>
-          </a:xfrm>
-          <a:prstGeom prst="roundRect">
-            <a:avLst/>
-          </a:prstGeom>
-          <a:solidFill>
-            <a:srgbClr val="EBF0F5"/>
-          </a:solidFill>
-          <a:ln>
-            <a:noFill/>
-          </a:ln>
-        </p:spPr>
-        <p:style>
-          <a:lnRef idx="1">
-            <a:schemeClr val="accent1"/>
-          </a:lnRef>
-          <a:fillRef idx="3">
-            <a:schemeClr val="accent1"/>
-          </a:fillRef>
-          <a:effectRef idx="2">
-            <a:schemeClr val="accent1"/>
-          </a:effectRef>
-          <a:fontRef idx="minor">
-            <a:schemeClr val="lt1"/>
-          </a:fontRef>
-        </p:style>
-        <p:txBody>
-          <a:bodyPr rtlCol="0" anchor="ctr"/>
-          <a:lstStyle/>
-          <a:p>
-            <a:pPr algn="ctr"/>
-          </a:p>
-        </p:txBody>
-      </p:sp>
-      <p:sp>
-        <p:nvSpPr>
-          <p:cNvPr id="38" name="Rounded Rectangle 37"/>
-          <p:cNvSpPr/>
-          <p:nvPr/>
-        </p:nvSpPr>
-        <p:spPr>
-          <a:xfrm>
-            <a:off x="731527" y="1463042"/>
-            <a:ext cx="2057400" cy="2240280"/>
-          </a:xfrm>
-          <a:prstGeom prst="roundRect">
-            <a:avLst/>
-          </a:prstGeom>
-          <a:solidFill>
-            <a:srgbClr val="FFFFFF"/>
-          </a:solidFill>
-          <a:ln>
-            <a:solidFill>
-              <a:srgbClr val="E2E8F0"/>
-            </a:solidFill>
-          </a:ln>
-        </p:spPr>
-        <p:style>
-          <a:lnRef idx="1">
-            <a:schemeClr val="accent1"/>
-          </a:lnRef>
-          <a:fillRef idx="3">
-            <a:schemeClr val="accent1"/>
-          </a:fillRef>
-          <a:effectRef idx="2">
-            <a:schemeClr val="accent1"/>
-          </a:effectRef>
-          <a:fontRef idx="minor">
-            <a:schemeClr val="lt1"/>
-          </a:fontRef>
-        </p:style>
-        <p:txBody>
-          <a:bodyPr rtlCol="0" anchor="ctr"/>
-          <a:lstStyle/>
-          <a:p>
-            <a:pPr algn="ctr"/>
-          </a:p>
-        </p:txBody>
-      </p:sp>
-      <p:sp>
-        <p:nvSpPr>
-          <p:cNvPr id="39" name="Rectangle 38"/>
-          <p:cNvSpPr/>
-          <p:nvPr/>
-        </p:nvSpPr>
-        <p:spPr>
-          <a:xfrm>
-            <a:off x="731527" y="1463042"/>
-            <a:ext cx="2057400" cy="50800"/>
-          </a:xfrm>
-          <a:prstGeom prst="rect">
-            <a:avLst/>
-          </a:prstGeom>
-          <a:solidFill>
-            <a:srgbClr val="4338CA"/>
-          </a:solidFill>
-          <a:ln>
-            <a:noFill/>
-          </a:ln>
-        </p:spPr>
-        <p:style>
-          <a:lnRef idx="1">
-            <a:schemeClr val="accent1"/>
-          </a:lnRef>
-          <a:fillRef idx="3">
-            <a:schemeClr val="accent1"/>
-          </a:fillRef>
-          <a:effectRef idx="2">
-            <a:schemeClr val="accent1"/>
-          </a:effectRef>
-          <a:fontRef idx="minor">
-            <a:schemeClr val="lt1"/>
-          </a:fontRef>
-        </p:style>
-        <p:txBody>
-          <a:bodyPr rtlCol="0" anchor="ctr"/>
-          <a:lstStyle/>
-          <a:p>
-            <a:pPr algn="ctr"/>
-          </a:p>
-        </p:txBody>
-      </p:sp>
-      <p:sp>
-        <p:nvSpPr>
-          <p:cNvPr id="40" name="TextBox 39"/>
-          <p:cNvSpPr txBox="1"/>
-          <p:nvPr/>
-        </p:nvSpPr>
-        <p:spPr>
-          <a:xfrm>
-            <a:off x="841255" y="1600202"/>
-            <a:ext cx="1828800" cy="1965960"/>
-          </a:xfrm>
-          <a:prstGeom prst="rect">
-            <a:avLst/>
-          </a:prstGeom>
-          <a:noFill/>
-        </p:spPr>
-        <p:txBody>
-          <a:bodyPr wrap="square">
-            <a:spAutoFit/>
-          </a:bodyPr>
-          <a:lstStyle/>
-          <a:p>
-            <a:pPr>
-              <a:defRPr sz="1300" b="1">
-                <a:solidFill>
-                  <a:srgbClr val="0F172A"/>
-                </a:solidFill>
-                <a:latin typeface="Inter"/>
-              </a:defRPr>
-            </a:pPr>
-            <a:r>
-              <a:t>Notification Agent</a:t>
-            </a:r>
-          </a:p>
-          <a:p>
-            <a:pPr>
-              <a:spcBef>
-                <a:spcPts val="600"/>
-              </a:spcBef>
-              <a:defRPr sz="1000">
-                <a:solidFill>
-                  <a:srgbClr val="64748B"/>
-                </a:solidFill>
-                <a:latin typeface="Inter"/>
-              </a:defRPr>
-            </a:pPr>
-            <a:r>
-              <a:t>Real-time WebSocket event stream broadcaster</a:t>
-            </a:r>
-          </a:p>
-        </p:txBody>
-      </p:sp>
-      <p:sp>
-        <p:nvSpPr>
-          <p:cNvPr id="41" name="Rounded Rectangle 40"/>
-          <p:cNvSpPr/>
-          <p:nvPr/>
-        </p:nvSpPr>
-        <p:spPr>
-          <a:xfrm>
-            <a:off x="768105" y="1499618"/>
-            <a:ext cx="2057400" cy="2240280"/>
-          </a:xfrm>
-          <a:prstGeom prst="roundRect">
-            <a:avLst/>
-          </a:prstGeom>
-          <a:solidFill>
-            <a:srgbClr val="EBF0F5"/>
-          </a:solidFill>
-          <a:ln>
-            <a:noFill/>
-          </a:ln>
-        </p:spPr>
-        <p:style>
-          <a:lnRef idx="1">
-            <a:schemeClr val="accent1"/>
-          </a:lnRef>
-          <a:fillRef idx="3">
-            <a:schemeClr val="accent1"/>
-          </a:fillRef>
-          <a:effectRef idx="2">
-            <a:schemeClr val="accent1"/>
-          </a:effectRef>
-          <a:fontRef idx="minor">
-            <a:schemeClr val="lt1"/>
-          </a:fontRef>
-        </p:style>
-        <p:txBody>
-          <a:bodyPr rtlCol="0" anchor="ctr"/>
-          <a:lstStyle/>
-          <a:p>
-            <a:pPr algn="ctr"/>
-          </a:p>
-        </p:txBody>
-      </p:sp>
-      <p:sp>
-        <p:nvSpPr>
-          <p:cNvPr id="42" name="Rounded Rectangle 41"/>
-          <p:cNvSpPr/>
-          <p:nvPr/>
-        </p:nvSpPr>
-        <p:spPr>
-          <a:xfrm>
-            <a:off x="731529" y="1463042"/>
-            <a:ext cx="2057400" cy="2240280"/>
-          </a:xfrm>
-          <a:prstGeom prst="roundRect">
-            <a:avLst/>
-          </a:prstGeom>
-          <a:solidFill>
-            <a:srgbClr val="FFFFFF"/>
-          </a:solidFill>
-          <a:ln>
-            <a:solidFill>
-              <a:srgbClr val="E2E8F0"/>
-            </a:solidFill>
-          </a:ln>
-        </p:spPr>
-        <p:style>
-          <a:lnRef idx="1">
-            <a:schemeClr val="accent1"/>
-          </a:lnRef>
-          <a:fillRef idx="3">
-            <a:schemeClr val="accent1"/>
-          </a:fillRef>
-          <a:effectRef idx="2">
-            <a:schemeClr val="accent1"/>
-          </a:effectRef>
-          <a:fontRef idx="minor">
-            <a:schemeClr val="lt1"/>
-          </a:fontRef>
-        </p:style>
-        <p:txBody>
-          <a:bodyPr rtlCol="0" anchor="ctr"/>
-          <a:lstStyle/>
-          <a:p>
-            <a:pPr algn="ctr"/>
-          </a:p>
-        </p:txBody>
-      </p:sp>
-      <p:sp>
-        <p:nvSpPr>
-          <p:cNvPr id="43" name="Rectangle 42"/>
-          <p:cNvSpPr/>
-          <p:nvPr/>
-        </p:nvSpPr>
-        <p:spPr>
-          <a:xfrm>
-            <a:off x="731529" y="1463042"/>
-            <a:ext cx="2057400" cy="50800"/>
-          </a:xfrm>
-          <a:prstGeom prst="rect">
-            <a:avLst/>
-          </a:prstGeom>
-          <a:solidFill>
-            <a:srgbClr val="4338CA"/>
-          </a:solidFill>
-          <a:ln>
-            <a:noFill/>
-          </a:ln>
-        </p:spPr>
-        <p:style>
-          <a:lnRef idx="1">
-            <a:schemeClr val="accent1"/>
-          </a:lnRef>
-          <a:fillRef idx="3">
-            <a:schemeClr val="accent1"/>
-          </a:fillRef>
-          <a:effectRef idx="2">
-            <a:schemeClr val="accent1"/>
-          </a:effectRef>
-          <a:fontRef idx="minor">
-            <a:schemeClr val="lt1"/>
-          </a:fontRef>
-        </p:style>
-        <p:txBody>
-          <a:bodyPr rtlCol="0" anchor="ctr"/>
-          <a:lstStyle/>
-          <a:p>
-            <a:pPr algn="ctr"/>
-          </a:p>
-        </p:txBody>
-      </p:sp>
-      <p:sp>
-        <p:nvSpPr>
-          <p:cNvPr id="44" name="TextBox 43"/>
-          <p:cNvSpPr txBox="1"/>
-          <p:nvPr/>
-        </p:nvSpPr>
-        <p:spPr>
-          <a:xfrm>
-            <a:off x="841257" y="1600202"/>
-            <a:ext cx="1828800" cy="1965960"/>
-          </a:xfrm>
-          <a:prstGeom prst="rect">
-            <a:avLst/>
-          </a:prstGeom>
-          <a:noFill/>
-        </p:spPr>
-        <p:txBody>
-          <a:bodyPr wrap="square">
-            <a:spAutoFit/>
-          </a:bodyPr>
-          <a:lstStyle/>
-          <a:p>
-            <a:pPr>
-              <a:defRPr sz="1300" b="1">
-                <a:solidFill>
-                  <a:srgbClr val="0F172A"/>
-                </a:solidFill>
-                <a:latin typeface="Inter"/>
-              </a:defRPr>
-            </a:pPr>
-            <a:r>
-              <a:t>Analytics Agent</a:t>
-            </a:r>
-          </a:p>
-          <a:p>
-            <a:pPr>
-              <a:spcBef>
-                <a:spcPts val="600"/>
-              </a:spcBef>
-              <a:defRPr sz="1000">
-                <a:solidFill>
-                  <a:srgbClr val="64748B"/>
-                </a:solidFill>
-                <a:latin typeface="Inter"/>
-              </a:defRPr>
-            </a:pPr>
-            <a:r>
-              <a:t>Calculates 92/100 Health Score &amp; cash runway</a:t>
+              <a:t>Stores active workspace session state, draft invoice uploads, and UI filters for instant 0ms page loads and offline resilience.</a:t>
             </a:r>
           </a:p>
         </p:txBody>
@@ -9878,7 +8780,7 @@
               </a:defRPr>
             </a:pPr>
             <a:r>
-              <a:t>Strategic Product Roadmap</a:t>
+              <a:t>Strategic Roadmap &amp; Growth Vision</a:t>
             </a:r>
           </a:p>
           <a:p>
@@ -9891,7 +8793,7 @@
               </a:defRPr>
             </a:pPr>
             <a:r>
-              <a:t>Phased deployment plan for enterprise scaling across Chartered Accountancies</a:t>
+              <a:t>Phased expansion from MVP to Enterprise Chartered Accountancy Scaling</a:t>
             </a:r>
           </a:p>
         </p:txBody>
@@ -10085,23 +8987,23 @@
               </a:defRPr>
             </a:pPr>
             <a:r>
-              <a:t>• 10 Specialized AI Agents operational</a:t>
+              <a:t>• Hybrid Storage Engine (Supabase + Local)</a:t>
             </a:r>
             <a:br/>
             <a:r>
-              <a:t>• Immutable double-entry ledger core</a:t>
+              <a:t>• Double-entry ledger core engine</a:t>
             </a:r>
             <a:br/>
             <a:r>
-              <a:t>• GST &amp; TDS compliance engine</a:t>
+              <a:t>• Statutory GST &amp; TDS compliance</a:t>
             </a:r>
             <a:br/>
             <a:r>
-              <a:t>• Light Grey &amp; Trust Blue UX</a:t>
+              <a:t>• OpenAI Codex AI Architecture</a:t>
             </a:r>
             <a:br/>
             <a:r>
-              <a:t>• Google Gemini 2.5 Flash + SHA256 Cache</a:t>
+              <a:t>• 1-Tap Pre-Coded AI Tasks</a:t>
             </a:r>
           </a:p>
         </p:txBody>
@@ -10513,7 +9415,7 @@
             </a:r>
             <a:br/>
             <a:r>
-              <a:t>• Predictive working capital scoring</a:t>
+              <a:t>• Predictive working capital credit scoring</a:t>
             </a:r>
             <a:br/>
             <a:r>
@@ -10595,8 +9497,8 @@
         </p:nvSpPr>
         <p:spPr>
           <a:xfrm>
-            <a:off x="1371600" y="1828800"/>
-            <a:ext cx="9445752" cy="3200400"/>
+            <a:off x="1371600" y="1645920"/>
+            <a:ext cx="9445752" cy="3657600"/>
           </a:xfrm>
           <a:prstGeom prst="rect">
             <a:avLst/>
@@ -10618,7 +9520,7 @@
               </a:defRPr>
             </a:pPr>
             <a:r>
-              <a:t>Ready to Transform Your Indian Business Accounting?</a:t>
+              <a:t>Ready to Transform Indian Business Accounting?</a:t>
             </a:r>
           </a:p>
           <a:p>
@@ -10637,6 +9539,22 @@
               <a:t>Automate PDF invoice OCR, double-entry ledger posting, and statutory GST &amp; TDS compliance.</a:t>
             </a:r>
           </a:p>
+          <a:p>
+            <a:pPr algn="ctr">
+              <a:spcBef>
+                <a:spcPts val="2000"/>
+              </a:spcBef>
+              <a:defRPr sz="1400" b="1">
+                <a:solidFill>
+                  <a:srgbClr val="F0FDF4"/>
+                </a:solidFill>
+                <a:latin typeface="Inter"/>
+              </a:defRPr>
+            </a:pPr>
+            <a:r>
+              <a:t>GitHub: github.com/Abhitech-st/Vyapar-Mandap</a:t>
+            </a:r>
+          </a:p>
         </p:txBody>
       </p:sp>
       <p:sp>
@@ -10647,7 +9565,7 @@
         </p:nvSpPr>
         <p:spPr>
           <a:xfrm>
-            <a:off x="4261104" y="4754880"/>
+            <a:off x="4261104" y="4937760"/>
             <a:ext cx="3657600" cy="685800"/>
           </a:xfrm>
           <a:prstGeom prst="roundRect">
@@ -10692,7 +9610,7 @@
         </p:nvSpPr>
         <p:spPr>
           <a:xfrm>
-            <a:off x="4261104" y="4754880"/>
+            <a:off x="4261104" y="4937760"/>
             <a:ext cx="3657600" cy="685800"/>
           </a:xfrm>
           <a:prstGeom prst="rect">
@@ -10715,7 +9633,7 @@
               </a:defRPr>
             </a:pPr>
             <a:r>
-              <a:t>Explore Vyapar Mandap Live</a:t>
+              <a:t>Explore Live Platform Demo</a:t>
             </a:r>
           </a:p>
         </p:txBody>

</xml_diff>